<commit_message>
fix(pptx): embed speaker notes in PowerPoint's own Notes pane
The committed .pptx had every slide's content and charts but no
speaker notes — pptxgenjs needs an explicit addNotes() call, which
buildDeck.ts never made. Extracted the 14 notes into
src/data/deckNotes.ts (shared with the website's /present view, so
the two can't drift), wired it into both, and regenerated the file.
</commit_message>
<xml_diff>
--- a/Mini-DDSM-CSDE2026-Presentation.pptx
+++ b/Mini-DDSM-CSDE2026-Presentation.pptx
@@ -1511,7 +1511,7 @@
           <a:p>
             <a:r>
               <a:rPr lang="en-US" dirty="0"/>
-              <a:t/>
+              <a:t>Good morning. I'm Sheikh Noor Abdullah from BAUET. Our paper asks a simple question: how good is breast-cancer classification on Mini-DDSM when we evaluate it honestly, patient by patient?</a:t>
             </a:r>
             <a:endParaRPr lang="en-US" dirty="0"/>
           </a:p>
@@ -1599,7 +1599,7 @@
           <a:p>
             <a:r>
               <a:rPr lang="en-US" dirty="0"/>
-              <a:t/>
+              <a:t>Platt scaling, fit only on inner validation, lowers Brier from 0.136 to 0.124 and ECE from 0.075 to 0.023. Decision-curve analysis shows positive net benefit from 0.05 to 0.80 in every seed — still internal evidence only.</a:t>
             </a:r>
             <a:endParaRPr lang="en-US" dirty="0"/>
           </a:p>
@@ -1687,7 +1687,7 @@
           <a:p>
             <a:r>
               <a:rPr lang="en-US" dirty="0"/>
-              <a:t/>
+              <a:t>Grad-CAM gives a qualitative look. For true positives, attention concentrates on the lesion; for false negatives it's near the lesion but too weak. We present this as a transparency aid, not validated localisation.</a:t>
             </a:r>
             <a:endParaRPr lang="en-US" dirty="0"/>
           </a:p>
@@ -1775,7 +1775,7 @@
           <a:p>
             <a:r>
               <a:rPr lang="en-US" dirty="0"/>
-              <a:t/>
+              <a:t>Limitations: one dataset, three folds, eight-image identifiers kept as conservative groups, and Grad-CAM is qualitative. Next we'll apply the same protocol to CBIS-DDSM and INbreast with radiologist review.</a:t>
             </a:r>
             <a:endParaRPr lang="en-US" dirty="0"/>
           </a:p>
@@ -1863,7 +1863,7 @@
           <a:p>
             <a:r>
               <a:rPr lang="en-US" dirty="0"/>
-              <a:t/>
+              <a:t>To summarise: audit first, a simple ensemble wins, thresholds matter, and we're honest about the limits. Everything — code, splits and audit files — is public. Scan the QR code to try the live demo on your own phone. Thank you; happy to take questions.</a:t>
             </a:r>
             <a:endParaRPr lang="en-US" dirty="0"/>
           </a:p>
@@ -1951,7 +1951,7 @@
           <a:p>
             <a:r>
               <a:rPr lang="en-US" dirty="0"/>
-              <a:t/>
+              <a:t>That's the talk. I'm glad to take questions — on the patient-grouping protocol, the ensemble, the thresholds, or what we'd do differently on a second dataset.</a:t>
             </a:r>
             <a:endParaRPr lang="en-US" dirty="0"/>
           </a:p>
@@ -2039,7 +2039,7 @@
           <a:p>
             <a:r>
               <a:rPr lang="en-US" dirty="0"/>
-              <a:t/>
+              <a:t>Breast cancer is the most diagnosed cancer in women — 2.43 million new cases in GLOBOCAN 2024. Deep learning can help screening, but reported accuracy depends heavily on how the data are split.</a:t>
             </a:r>
             <a:endParaRPr lang="en-US" dirty="0"/>
           </a:p>
@@ -2127,7 +2127,7 @@
           <a:p>
             <a:r>
               <a:rPr lang="en-US" dirty="0"/>
-              <a:t/>
+              <a:t>Here's the catch. Mini-DDSM has several views per patient. If a patient's CC and MLO images fall on both sides of the split, the model is partly tested on someone it has already seen. Several prior papers report 0.87 to 0.99 accuracy without saying whether they grouped by patient.</a:t>
             </a:r>
             <a:endParaRPr lang="en-US" dirty="0"/>
           </a:p>
@@ -2215,7 +2215,7 @@
           <a:p>
             <a:r>
               <a:rPr lang="en-US" dirty="0"/>
-              <a:t/>
+              <a:t>So before building any fold, we audited every identifier. Three raw IDs appear in both Benign and Cancer folders — we key groups by class folder plus ID. Four eight-image blocks are kept intact. Fourteen exact duplicate pairs, none crossing groups. Result: 2,417 patient groups and zero leakage on all nine splits.</a:t>
             </a:r>
             <a:endParaRPr lang="en-US" dirty="0"/>
           </a:p>
@@ -2303,7 +2303,7 @@
           <a:p>
             <a:r>
               <a:rPr lang="en-US" dirty="0"/>
-              <a:t/>
+              <a:t>The pipeline is deliberately simple. Otsu crop to 512, four-view test-time augmentation, two ImageNet backbones, average to a patient score, then a fixed 50/50 ensemble — no weights tuned on test data.</a:t>
             </a:r>
             <a:endParaRPr lang="en-US" dirty="0"/>
           </a:p>
@@ -2391,7 +2391,7 @@
           <a:p>
             <a:r>
               <a:rPr lang="en-US" dirty="0"/>
-              <a:t/>
+              <a:t>Evaluation is nested. Each outer training fold is split into inner train and inner validation by patient. Checkpoints, Youden thresholds and Platt scaling come only from inner validation, then are frozen. The outer test fold is untouched until the end. We repeat everything with three seeds.</a:t>
             </a:r>
             <a:endParaRPr lang="en-US" dirty="0"/>
           </a:p>
@@ -2479,7 +2479,7 @@
           <a:p>
             <a:r>
               <a:rPr lang="en-US" dirty="0"/>
-              <a:t/>
+              <a:t>Across three seeds, the ensemble reaches ROC-AUC 0.891 plus-minus 0.008 and PR-AUC 0.830. That beats EfficientNet-B4 at 0.882, ConvNeXtV2 at 0.857 and the fold-selected single best at 0.878.</a:t>
             </a:r>
             <a:endParaRPr lang="en-US" dirty="0"/>
           </a:p>
@@ -2567,7 +2567,7 @@
           <a:p>
             <a:r>
               <a:rPr lang="en-US" dirty="0"/>
-              <a:t/>
+              <a:t>The ablation shows the fixed average wins on five of six metrics. EfficientNet alone stays more sensitive at 0.5 — so the ensemble improves discrimination but doesn't dominate every operating point.</a:t>
             </a:r>
             <a:endParaRPr lang="en-US" dirty="0"/>
           </a:p>
@@ -2655,7 +2655,7 @@
           <a:p>
             <a:r>
               <a:rPr lang="en-US" dirty="0"/>
-              <a:t/>
+              <a:t>Ranking isn't the whole story. At 0.5 the model is specific — 92.6% — but misses many cancers. Using the Youden threshold chosen on training-side validation raises sensitivity from 0.62 to 0.79 and cuts missed cancers from about 343 to 191 per seed.</a:t>
             </a:r>
             <a:endParaRPr lang="en-US" dirty="0"/>
           </a:p>
@@ -3069,7 +3069,7 @@
       </p:sp>
       <p:sp>
         <p:nvSpPr>
-          <p:cNvPr id="3" name="Shape 1"/>
+          <p:cNvPr id="4" name="Shape 1"/>
           <p:cNvSpPr/>
           <p:nvPr/>
         </p:nvSpPr>
@@ -3096,7 +3096,7 @@
       </p:sp>
       <p:sp>
         <p:nvSpPr>
-          <p:cNvPr id="4" name="Text 2"/>
+          <p:cNvPr id="5" name="Text 2"/>
           <p:cNvSpPr/>
           <p:nvPr/>
         </p:nvSpPr>
@@ -3135,7 +3135,7 @@
       </p:sp>
       <p:sp>
         <p:nvSpPr>
-          <p:cNvPr id="5" name="Text 3"/>
+          <p:cNvPr id="6" name="Text 3"/>
           <p:cNvSpPr/>
           <p:nvPr/>
         </p:nvSpPr>
@@ -3211,7 +3211,7 @@
       </p:sp>
       <p:sp>
         <p:nvSpPr>
-          <p:cNvPr id="6" name="Text 4"/>
+          <p:cNvPr id="7" name="Text 4"/>
           <p:cNvSpPr/>
           <p:nvPr/>
         </p:nvSpPr>
@@ -3250,7 +3250,7 @@
       </p:sp>
       <p:sp>
         <p:nvSpPr>
-          <p:cNvPr id="7" name="Text 5"/>
+          <p:cNvPr id="8" name="Text 5"/>
           <p:cNvSpPr/>
           <p:nvPr/>
         </p:nvSpPr>
@@ -3289,7 +3289,7 @@
       </p:sp>
       <p:sp>
         <p:nvSpPr>
-          <p:cNvPr id="8" name="Shape 6"/>
+          <p:cNvPr id="9" name="Shape 6"/>
           <p:cNvSpPr/>
           <p:nvPr/>
         </p:nvSpPr>
@@ -3316,7 +3316,7 @@
       </p:sp>
       <p:sp>
         <p:nvSpPr>
-          <p:cNvPr id="9" name="Text 7"/>
+          <p:cNvPr id="10" name="Text 7"/>
           <p:cNvSpPr/>
           <p:nvPr/>
         </p:nvSpPr>
@@ -3355,7 +3355,7 @@
       </p:sp>
       <p:sp>
         <p:nvSpPr>
-          <p:cNvPr id="10" name="Text 8"/>
+          <p:cNvPr id="11" name="Text 8"/>
           <p:cNvSpPr/>
           <p:nvPr/>
         </p:nvSpPr>
@@ -3394,7 +3394,7 @@
       </p:sp>
       <p:sp>
         <p:nvSpPr>
-          <p:cNvPr id="11" name="Shape 9"/>
+          <p:cNvPr id="12" name="Shape 9"/>
           <p:cNvSpPr/>
           <p:nvPr/>
         </p:nvSpPr>
@@ -3421,7 +3421,7 @@
       </p:sp>
       <p:sp>
         <p:nvSpPr>
-          <p:cNvPr id="12" name="Text 10"/>
+          <p:cNvPr id="13" name="Text 10"/>
           <p:cNvSpPr/>
           <p:nvPr/>
         </p:nvSpPr>
@@ -3460,7 +3460,7 @@
       </p:sp>
       <p:sp>
         <p:nvSpPr>
-          <p:cNvPr id="13" name="Text 11"/>
+          <p:cNvPr id="14" name="Text 11"/>
           <p:cNvSpPr/>
           <p:nvPr/>
         </p:nvSpPr>
@@ -3499,7 +3499,7 @@
       </p:sp>
       <p:sp>
         <p:nvSpPr>
-          <p:cNvPr id="14" name="Shape 12"/>
+          <p:cNvPr id="15" name="Shape 12"/>
           <p:cNvSpPr/>
           <p:nvPr/>
         </p:nvSpPr>
@@ -3526,7 +3526,7 @@
       </p:sp>
       <p:sp>
         <p:nvSpPr>
-          <p:cNvPr id="15" name="Text 13"/>
+          <p:cNvPr id="16" name="Text 13"/>
           <p:cNvSpPr/>
           <p:nvPr/>
         </p:nvSpPr>
@@ -3565,7 +3565,7 @@
       </p:sp>
       <p:sp>
         <p:nvSpPr>
-          <p:cNvPr id="16" name="Text 14"/>
+          <p:cNvPr id="17" name="Text 14"/>
           <p:cNvSpPr/>
           <p:nvPr/>
         </p:nvSpPr>
@@ -3675,7 +3675,7 @@
       </p:sp>
       <p:sp>
         <p:nvSpPr>
-          <p:cNvPr id="3" name="Shape 1"/>
+          <p:cNvPr id="4" name="Shape 1"/>
           <p:cNvSpPr/>
           <p:nvPr/>
         </p:nvSpPr>
@@ -3698,7 +3698,7 @@
       </p:sp>
       <p:sp>
         <p:nvSpPr>
-          <p:cNvPr id="4" name="Text 2"/>
+          <p:cNvPr id="5" name="Text 2"/>
           <p:cNvSpPr/>
           <p:nvPr/>
         </p:nvSpPr>
@@ -3737,7 +3737,7 @@
       </p:sp>
       <p:sp>
         <p:nvSpPr>
-          <p:cNvPr id="5" name="Text 3"/>
+          <p:cNvPr id="6" name="Text 3"/>
           <p:cNvSpPr/>
           <p:nvPr/>
         </p:nvSpPr>
@@ -3779,7 +3779,7 @@
       </p:sp>
       <p:sp>
         <p:nvSpPr>
-          <p:cNvPr id="6" name="Shape 4"/>
+          <p:cNvPr id="7" name="Shape 4"/>
           <p:cNvSpPr/>
           <p:nvPr/>
         </p:nvSpPr>
@@ -3806,7 +3806,7 @@
       </p:sp>
       <p:sp>
         <p:nvSpPr>
-          <p:cNvPr id="7" name="Text 5"/>
+          <p:cNvPr id="8" name="Text 5"/>
           <p:cNvSpPr/>
           <p:nvPr/>
         </p:nvSpPr>
@@ -3845,7 +3845,7 @@
       </p:sp>
       <p:sp>
         <p:nvSpPr>
-          <p:cNvPr id="8" name="Text 6"/>
+          <p:cNvPr id="9" name="Text 6"/>
           <p:cNvSpPr/>
           <p:nvPr/>
         </p:nvSpPr>
@@ -3884,7 +3884,7 @@
       </p:sp>
       <p:sp>
         <p:nvSpPr>
-          <p:cNvPr id="9" name="Shape 7"/>
+          <p:cNvPr id="10" name="Shape 7"/>
           <p:cNvSpPr/>
           <p:nvPr/>
         </p:nvSpPr>
@@ -3911,7 +3911,7 @@
       </p:sp>
       <p:sp>
         <p:nvSpPr>
-          <p:cNvPr id="10" name="Text 8"/>
+          <p:cNvPr id="11" name="Text 8"/>
           <p:cNvSpPr/>
           <p:nvPr/>
         </p:nvSpPr>
@@ -3950,7 +3950,7 @@
       </p:sp>
       <p:sp>
         <p:nvSpPr>
-          <p:cNvPr id="11" name="Text 9"/>
+          <p:cNvPr id="12" name="Text 9"/>
           <p:cNvSpPr/>
           <p:nvPr/>
         </p:nvSpPr>
@@ -3989,7 +3989,7 @@
       </p:sp>
       <p:sp>
         <p:nvSpPr>
-          <p:cNvPr id="12" name="Shape 10"/>
+          <p:cNvPr id="13" name="Shape 10"/>
           <p:cNvSpPr/>
           <p:nvPr/>
         </p:nvSpPr>
@@ -4016,7 +4016,7 @@
       </p:sp>
       <p:sp>
         <p:nvSpPr>
-          <p:cNvPr id="13" name="Text 11"/>
+          <p:cNvPr id="14" name="Text 11"/>
           <p:cNvSpPr/>
           <p:nvPr/>
         </p:nvSpPr>
@@ -4055,7 +4055,7 @@
       </p:sp>
       <p:sp>
         <p:nvSpPr>
-          <p:cNvPr id="14" name="Text 12"/>
+          <p:cNvPr id="15" name="Text 12"/>
           <p:cNvSpPr/>
           <p:nvPr/>
         </p:nvSpPr>
@@ -4094,7 +4094,7 @@
       </p:sp>
       <p:sp>
         <p:nvSpPr>
-          <p:cNvPr id="15" name="Text 13"/>
+          <p:cNvPr id="16" name="Text 13"/>
           <p:cNvSpPr/>
           <p:nvPr/>
         </p:nvSpPr>
@@ -4204,7 +4204,7 @@
       </p:sp>
       <p:sp>
         <p:nvSpPr>
-          <p:cNvPr id="3" name="Shape 1"/>
+          <p:cNvPr id="4" name="Shape 1"/>
           <p:cNvSpPr/>
           <p:nvPr/>
         </p:nvSpPr>
@@ -4227,7 +4227,7 @@
       </p:sp>
       <p:sp>
         <p:nvSpPr>
-          <p:cNvPr id="4" name="Text 2"/>
+          <p:cNvPr id="5" name="Text 2"/>
           <p:cNvSpPr/>
           <p:nvPr/>
         </p:nvSpPr>
@@ -4266,7 +4266,7 @@
       </p:sp>
       <p:sp>
         <p:nvSpPr>
-          <p:cNvPr id="5" name="Text 3"/>
+          <p:cNvPr id="6" name="Text 3"/>
           <p:cNvSpPr/>
           <p:nvPr/>
         </p:nvSpPr>
@@ -4308,7 +4308,7 @@
       </p:sp>
       <p:pic>
         <p:nvPicPr>
-          <p:cNvPr id="6" name="Image 0" descr="preencoded.png">    </p:cNvPr>
+          <p:cNvPr id="7" name="Image 0" descr="preencoded.png">    </p:cNvPr>
           <p:cNvPicPr>
             <a:picLocks noChangeAspect="1"/>
           </p:cNvPicPr>
@@ -4331,7 +4331,7 @@
       </p:pic>
       <p:sp>
         <p:nvSpPr>
-          <p:cNvPr id="7" name="Text 4"/>
+          <p:cNvPr id="8" name="Text 4"/>
           <p:cNvSpPr/>
           <p:nvPr/>
         </p:nvSpPr>
@@ -4370,7 +4370,7 @@
       </p:sp>
       <p:pic>
         <p:nvPicPr>
-          <p:cNvPr id="8" name="Image 1" descr="preencoded.png">    </p:cNvPr>
+          <p:cNvPr id="9" name="Image 1" descr="preencoded.png">    </p:cNvPr>
           <p:cNvPicPr>
             <a:picLocks noChangeAspect="1"/>
           </p:cNvPicPr>
@@ -4393,7 +4393,7 @@
       </p:pic>
       <p:sp>
         <p:nvSpPr>
-          <p:cNvPr id="9" name="Text 5"/>
+          <p:cNvPr id="10" name="Text 5"/>
           <p:cNvSpPr/>
           <p:nvPr/>
         </p:nvSpPr>
@@ -4432,7 +4432,7 @@
       </p:sp>
       <p:pic>
         <p:nvPicPr>
-          <p:cNvPr id="10" name="Image 2" descr="preencoded.png">    </p:cNvPr>
+          <p:cNvPr id="11" name="Image 2" descr="preencoded.png">    </p:cNvPr>
           <p:cNvPicPr>
             <a:picLocks noChangeAspect="1"/>
           </p:cNvPicPr>
@@ -4455,7 +4455,7 @@
       </p:pic>
       <p:sp>
         <p:nvSpPr>
-          <p:cNvPr id="11" name="Text 6"/>
+          <p:cNvPr id="12" name="Text 6"/>
           <p:cNvSpPr/>
           <p:nvPr/>
         </p:nvSpPr>
@@ -4494,7 +4494,7 @@
       </p:sp>
       <p:pic>
         <p:nvPicPr>
-          <p:cNvPr id="12" name="Image 3" descr="preencoded.png">    </p:cNvPr>
+          <p:cNvPr id="13" name="Image 3" descr="preencoded.png">    </p:cNvPr>
           <p:cNvPicPr>
             <a:picLocks noChangeAspect="1"/>
           </p:cNvPicPr>
@@ -4517,7 +4517,7 @@
       </p:pic>
       <p:sp>
         <p:nvSpPr>
-          <p:cNvPr id="13" name="Text 7"/>
+          <p:cNvPr id="14" name="Text 7"/>
           <p:cNvSpPr/>
           <p:nvPr/>
         </p:nvSpPr>
@@ -4627,7 +4627,7 @@
       </p:sp>
       <p:sp>
         <p:nvSpPr>
-          <p:cNvPr id="3" name="Shape 1"/>
+          <p:cNvPr id="4" name="Shape 1"/>
           <p:cNvSpPr/>
           <p:nvPr/>
         </p:nvSpPr>
@@ -4650,7 +4650,7 @@
       </p:sp>
       <p:sp>
         <p:nvSpPr>
-          <p:cNvPr id="4" name="Text 2"/>
+          <p:cNvPr id="5" name="Text 2"/>
           <p:cNvSpPr/>
           <p:nvPr/>
         </p:nvSpPr>
@@ -4689,7 +4689,7 @@
       </p:sp>
       <p:sp>
         <p:nvSpPr>
-          <p:cNvPr id="5" name="Text 3"/>
+          <p:cNvPr id="6" name="Text 3"/>
           <p:cNvSpPr/>
           <p:nvPr/>
         </p:nvSpPr>
@@ -4731,7 +4731,7 @@
       </p:sp>
       <p:sp>
         <p:nvSpPr>
-          <p:cNvPr id="6" name="Shape 4"/>
+          <p:cNvPr id="7" name="Shape 4"/>
           <p:cNvSpPr/>
           <p:nvPr/>
         </p:nvSpPr>
@@ -4758,7 +4758,7 @@
       </p:sp>
       <p:sp>
         <p:nvSpPr>
-          <p:cNvPr id="7" name="Text 5"/>
+          <p:cNvPr id="8" name="Text 5"/>
           <p:cNvSpPr/>
           <p:nvPr/>
         </p:nvSpPr>
@@ -4797,7 +4797,7 @@
       </p:sp>
       <p:sp>
         <p:nvSpPr>
-          <p:cNvPr id="8" name="Text 6"/>
+          <p:cNvPr id="9" name="Text 6"/>
           <p:cNvSpPr/>
           <p:nvPr/>
         </p:nvSpPr>
@@ -4836,7 +4836,7 @@
       </p:sp>
       <p:sp>
         <p:nvSpPr>
-          <p:cNvPr id="9" name="Shape 7"/>
+          <p:cNvPr id="10" name="Shape 7"/>
           <p:cNvSpPr/>
           <p:nvPr/>
         </p:nvSpPr>
@@ -4863,7 +4863,7 @@
       </p:sp>
       <p:sp>
         <p:nvSpPr>
-          <p:cNvPr id="10" name="Text 8"/>
+          <p:cNvPr id="11" name="Text 8"/>
           <p:cNvSpPr/>
           <p:nvPr/>
         </p:nvSpPr>
@@ -4902,7 +4902,7 @@
       </p:sp>
       <p:sp>
         <p:nvSpPr>
-          <p:cNvPr id="11" name="Text 9"/>
+          <p:cNvPr id="12" name="Text 9"/>
           <p:cNvSpPr/>
           <p:nvPr/>
         </p:nvSpPr>
@@ -4941,7 +4941,7 @@
       </p:sp>
       <p:sp>
         <p:nvSpPr>
-          <p:cNvPr id="12" name="Shape 10"/>
+          <p:cNvPr id="13" name="Shape 10"/>
           <p:cNvSpPr/>
           <p:nvPr/>
         </p:nvSpPr>
@@ -4968,7 +4968,7 @@
       </p:sp>
       <p:sp>
         <p:nvSpPr>
-          <p:cNvPr id="13" name="Text 11"/>
+          <p:cNvPr id="14" name="Text 11"/>
           <p:cNvSpPr/>
           <p:nvPr/>
         </p:nvSpPr>
@@ -5007,7 +5007,7 @@
       </p:sp>
       <p:sp>
         <p:nvSpPr>
-          <p:cNvPr id="14" name="Text 12"/>
+          <p:cNvPr id="15" name="Text 12"/>
           <p:cNvSpPr/>
           <p:nvPr/>
         </p:nvSpPr>
@@ -5046,7 +5046,7 @@
       </p:sp>
       <p:sp>
         <p:nvSpPr>
-          <p:cNvPr id="15" name="Shape 13"/>
+          <p:cNvPr id="16" name="Shape 13"/>
           <p:cNvSpPr/>
           <p:nvPr/>
         </p:nvSpPr>
@@ -5073,7 +5073,7 @@
       </p:sp>
       <p:sp>
         <p:nvSpPr>
-          <p:cNvPr id="16" name="Text 14"/>
+          <p:cNvPr id="17" name="Text 14"/>
           <p:cNvSpPr/>
           <p:nvPr/>
         </p:nvSpPr>
@@ -5112,7 +5112,7 @@
       </p:sp>
       <p:sp>
         <p:nvSpPr>
-          <p:cNvPr id="17" name="Text 15"/>
+          <p:cNvPr id="18" name="Text 15"/>
           <p:cNvSpPr/>
           <p:nvPr/>
         </p:nvSpPr>
@@ -5151,7 +5151,7 @@
       </p:sp>
       <p:sp>
         <p:nvSpPr>
-          <p:cNvPr id="18" name="Text 16"/>
+          <p:cNvPr id="19" name="Text 16"/>
           <p:cNvSpPr/>
           <p:nvPr/>
         </p:nvSpPr>
@@ -5261,7 +5261,7 @@
       </p:sp>
       <p:sp>
         <p:nvSpPr>
-          <p:cNvPr id="3" name="Shape 1"/>
+          <p:cNvPr id="4" name="Shape 1"/>
           <p:cNvSpPr/>
           <p:nvPr/>
         </p:nvSpPr>
@@ -5284,7 +5284,7 @@
       </p:sp>
       <p:sp>
         <p:nvSpPr>
-          <p:cNvPr id="4" name="Text 2"/>
+          <p:cNvPr id="5" name="Text 2"/>
           <p:cNvSpPr/>
           <p:nvPr/>
         </p:nvSpPr>
@@ -5323,7 +5323,7 @@
       </p:sp>
       <p:sp>
         <p:nvSpPr>
-          <p:cNvPr id="5" name="Shape 3"/>
+          <p:cNvPr id="6" name="Shape 3"/>
           <p:cNvSpPr/>
           <p:nvPr/>
         </p:nvSpPr>
@@ -5350,7 +5350,7 @@
       </p:sp>
       <p:sp>
         <p:nvSpPr>
-          <p:cNvPr id="6" name="Text 4"/>
+          <p:cNvPr id="7" name="Text 4"/>
           <p:cNvSpPr/>
           <p:nvPr/>
         </p:nvSpPr>
@@ -5391,7 +5391,7 @@
       </p:sp>
       <p:sp>
         <p:nvSpPr>
-          <p:cNvPr id="7" name="Text 5"/>
+          <p:cNvPr id="8" name="Text 5"/>
           <p:cNvSpPr/>
           <p:nvPr/>
         </p:nvSpPr>
@@ -5430,7 +5430,7 @@
       </p:sp>
       <p:sp>
         <p:nvSpPr>
-          <p:cNvPr id="8" name="Text 6"/>
+          <p:cNvPr id="9" name="Text 6"/>
           <p:cNvSpPr/>
           <p:nvPr/>
         </p:nvSpPr>
@@ -5469,7 +5469,7 @@
       </p:sp>
       <p:sp>
         <p:nvSpPr>
-          <p:cNvPr id="9" name="Shape 7"/>
+          <p:cNvPr id="10" name="Shape 7"/>
           <p:cNvSpPr/>
           <p:nvPr/>
         </p:nvSpPr>
@@ -5496,7 +5496,7 @@
       </p:sp>
       <p:sp>
         <p:nvSpPr>
-          <p:cNvPr id="10" name="Text 8"/>
+          <p:cNvPr id="11" name="Text 8"/>
           <p:cNvSpPr/>
           <p:nvPr/>
         </p:nvSpPr>
@@ -5537,7 +5537,7 @@
       </p:sp>
       <p:sp>
         <p:nvSpPr>
-          <p:cNvPr id="11" name="Text 9"/>
+          <p:cNvPr id="12" name="Text 9"/>
           <p:cNvSpPr/>
           <p:nvPr/>
         </p:nvSpPr>
@@ -5576,7 +5576,7 @@
       </p:sp>
       <p:sp>
         <p:nvSpPr>
-          <p:cNvPr id="12" name="Text 10"/>
+          <p:cNvPr id="13" name="Text 10"/>
           <p:cNvSpPr/>
           <p:nvPr/>
         </p:nvSpPr>
@@ -5615,7 +5615,7 @@
       </p:sp>
       <p:sp>
         <p:nvSpPr>
-          <p:cNvPr id="13" name="Shape 11"/>
+          <p:cNvPr id="14" name="Shape 11"/>
           <p:cNvSpPr/>
           <p:nvPr/>
         </p:nvSpPr>
@@ -5642,7 +5642,7 @@
       </p:sp>
       <p:sp>
         <p:nvSpPr>
-          <p:cNvPr id="14" name="Text 12"/>
+          <p:cNvPr id="15" name="Text 12"/>
           <p:cNvSpPr/>
           <p:nvPr/>
         </p:nvSpPr>
@@ -5683,7 +5683,7 @@
       </p:sp>
       <p:sp>
         <p:nvSpPr>
-          <p:cNvPr id="15" name="Text 13"/>
+          <p:cNvPr id="16" name="Text 13"/>
           <p:cNvSpPr/>
           <p:nvPr/>
         </p:nvSpPr>
@@ -5722,7 +5722,7 @@
       </p:sp>
       <p:sp>
         <p:nvSpPr>
-          <p:cNvPr id="16" name="Text 14"/>
+          <p:cNvPr id="17" name="Text 14"/>
           <p:cNvSpPr/>
           <p:nvPr/>
         </p:nvSpPr>
@@ -5761,7 +5761,7 @@
       </p:sp>
       <p:sp>
         <p:nvSpPr>
-          <p:cNvPr id="17" name="Shape 15"/>
+          <p:cNvPr id="18" name="Shape 15"/>
           <p:cNvSpPr/>
           <p:nvPr/>
         </p:nvSpPr>
@@ -5788,7 +5788,7 @@
       </p:sp>
       <p:sp>
         <p:nvSpPr>
-          <p:cNvPr id="18" name="Text 16"/>
+          <p:cNvPr id="19" name="Text 16"/>
           <p:cNvSpPr/>
           <p:nvPr/>
         </p:nvSpPr>
@@ -5829,7 +5829,7 @@
       </p:sp>
       <p:sp>
         <p:nvSpPr>
-          <p:cNvPr id="19" name="Text 17"/>
+          <p:cNvPr id="20" name="Text 17"/>
           <p:cNvSpPr/>
           <p:nvPr/>
         </p:nvSpPr>
@@ -5868,7 +5868,7 @@
       </p:sp>
       <p:sp>
         <p:nvSpPr>
-          <p:cNvPr id="20" name="Text 18"/>
+          <p:cNvPr id="21" name="Text 18"/>
           <p:cNvSpPr/>
           <p:nvPr/>
         </p:nvSpPr>
@@ -5907,7 +5907,7 @@
       </p:sp>
       <p:sp>
         <p:nvSpPr>
-          <p:cNvPr id="21" name="Text 19"/>
+          <p:cNvPr id="22" name="Text 19"/>
           <p:cNvSpPr/>
           <p:nvPr/>
         </p:nvSpPr>
@@ -5946,7 +5946,7 @@
       </p:sp>
       <p:sp>
         <p:nvSpPr>
-          <p:cNvPr id="22" name="Text 20"/>
+          <p:cNvPr id="23" name="Text 20"/>
           <p:cNvSpPr/>
           <p:nvPr/>
         </p:nvSpPr>
@@ -6006,7 +6006,7 @@
       </p:sp>
       <p:sp>
         <p:nvSpPr>
-          <p:cNvPr id="23" name="Shape 21"/>
+          <p:cNvPr id="24" name="Shape 21"/>
           <p:cNvSpPr/>
           <p:nvPr/>
         </p:nvSpPr>
@@ -6033,7 +6033,7 @@
       </p:sp>
       <p:sp>
         <p:nvSpPr>
-          <p:cNvPr id="24" name="Text 22"/>
+          <p:cNvPr id="25" name="Text 22"/>
           <p:cNvSpPr/>
           <p:nvPr/>
         </p:nvSpPr>
@@ -6072,7 +6072,7 @@
       </p:sp>
       <p:pic>
         <p:nvPicPr>
-          <p:cNvPr id="25" name="Image 0" descr="preencoded.png">    </p:cNvPr>
+          <p:cNvPr id="26" name="Image 0" descr="preencoded.png">    </p:cNvPr>
           <p:cNvPicPr>
             <a:picLocks noChangeAspect="1"/>
           </p:cNvPicPr>
@@ -6096,7 +6096,7 @@
       </p:pic>
       <p:sp>
         <p:nvSpPr>
-          <p:cNvPr id="26" name="Text 23"/>
+          <p:cNvPr id="27" name="Text 23"/>
           <p:cNvSpPr/>
           <p:nvPr/>
         </p:nvSpPr>
@@ -6135,7 +6135,7 @@
       </p:sp>
       <p:sp>
         <p:nvSpPr>
-          <p:cNvPr id="27" name="Text 24"/>
+          <p:cNvPr id="28" name="Text 24"/>
           <p:cNvSpPr/>
           <p:nvPr/>
         </p:nvSpPr>
@@ -6245,7 +6245,7 @@
       </p:sp>
       <p:sp>
         <p:nvSpPr>
-          <p:cNvPr id="3" name="Text 1"/>
+          <p:cNvPr id="4" name="Text 1"/>
           <p:cNvSpPr/>
           <p:nvPr/>
         </p:nvSpPr>
@@ -6286,7 +6286,7 @@
       </p:sp>
       <p:sp>
         <p:nvSpPr>
-          <p:cNvPr id="4" name="Shape 2"/>
+          <p:cNvPr id="5" name="Shape 2"/>
           <p:cNvSpPr/>
           <p:nvPr/>
         </p:nvSpPr>
@@ -6309,7 +6309,7 @@
       </p:sp>
       <p:sp>
         <p:nvSpPr>
-          <p:cNvPr id="5" name="Text 3"/>
+          <p:cNvPr id="6" name="Text 3"/>
           <p:cNvSpPr/>
           <p:nvPr/>
         </p:nvSpPr>
@@ -6348,7 +6348,7 @@
       </p:sp>
       <p:sp>
         <p:nvSpPr>
-          <p:cNvPr id="6" name="Text 4"/>
+          <p:cNvPr id="7" name="Text 4"/>
           <p:cNvSpPr/>
           <p:nvPr/>
         </p:nvSpPr>
@@ -6415,7 +6415,7 @@
       </p:sp>
       <p:sp>
         <p:nvSpPr>
-          <p:cNvPr id="7" name="Text 5"/>
+          <p:cNvPr id="8" name="Text 5"/>
           <p:cNvSpPr/>
           <p:nvPr/>
         </p:nvSpPr>
@@ -6457,7 +6457,7 @@
       </p:sp>
       <p:sp>
         <p:nvSpPr>
-          <p:cNvPr id="8" name="Shape 6"/>
+          <p:cNvPr id="9" name="Shape 6"/>
           <p:cNvSpPr/>
           <p:nvPr/>
         </p:nvSpPr>
@@ -6484,7 +6484,7 @@
       </p:sp>
       <p:sp>
         <p:nvSpPr>
-          <p:cNvPr id="9" name="Text 7"/>
+          <p:cNvPr id="10" name="Text 7"/>
           <p:cNvSpPr/>
           <p:nvPr/>
         </p:nvSpPr>
@@ -6523,7 +6523,7 @@
       </p:sp>
       <p:sp>
         <p:nvSpPr>
-          <p:cNvPr id="10" name="Text 8"/>
+          <p:cNvPr id="11" name="Text 8"/>
           <p:cNvSpPr/>
           <p:nvPr/>
         </p:nvSpPr>
@@ -6562,7 +6562,7 @@
       </p:sp>
       <p:sp>
         <p:nvSpPr>
-          <p:cNvPr id="11" name="Shape 9"/>
+          <p:cNvPr id="12" name="Shape 9"/>
           <p:cNvSpPr/>
           <p:nvPr/>
         </p:nvSpPr>
@@ -6589,7 +6589,7 @@
       </p:sp>
       <p:sp>
         <p:nvSpPr>
-          <p:cNvPr id="12" name="Text 10"/>
+          <p:cNvPr id="13" name="Text 10"/>
           <p:cNvSpPr/>
           <p:nvPr/>
         </p:nvSpPr>
@@ -6628,7 +6628,7 @@
       </p:sp>
       <p:sp>
         <p:nvSpPr>
-          <p:cNvPr id="13" name="Text 11"/>
+          <p:cNvPr id="14" name="Text 11"/>
           <p:cNvSpPr/>
           <p:nvPr/>
         </p:nvSpPr>
@@ -6667,7 +6667,7 @@
       </p:sp>
       <p:sp>
         <p:nvSpPr>
-          <p:cNvPr id="14" name="Shape 12"/>
+          <p:cNvPr id="15" name="Shape 12"/>
           <p:cNvSpPr/>
           <p:nvPr/>
         </p:nvSpPr>
@@ -6694,7 +6694,7 @@
       </p:sp>
       <p:sp>
         <p:nvSpPr>
-          <p:cNvPr id="15" name="Text 13"/>
+          <p:cNvPr id="16" name="Text 13"/>
           <p:cNvSpPr/>
           <p:nvPr/>
         </p:nvSpPr>
@@ -6733,7 +6733,7 @@
       </p:sp>
       <p:sp>
         <p:nvSpPr>
-          <p:cNvPr id="16" name="Text 14"/>
+          <p:cNvPr id="17" name="Text 14"/>
           <p:cNvSpPr/>
           <p:nvPr/>
         </p:nvSpPr>
@@ -6843,7 +6843,7 @@
       </p:sp>
       <p:sp>
         <p:nvSpPr>
-          <p:cNvPr id="3" name="Shape 1"/>
+          <p:cNvPr id="4" name="Shape 1"/>
           <p:cNvSpPr/>
           <p:nvPr/>
         </p:nvSpPr>
@@ -6866,7 +6866,7 @@
       </p:sp>
       <p:sp>
         <p:nvSpPr>
-          <p:cNvPr id="4" name="Text 2"/>
+          <p:cNvPr id="5" name="Text 2"/>
           <p:cNvSpPr/>
           <p:nvPr/>
         </p:nvSpPr>
@@ -6905,7 +6905,7 @@
       </p:sp>
       <p:sp>
         <p:nvSpPr>
-          <p:cNvPr id="5" name="Text 3"/>
+          <p:cNvPr id="6" name="Text 3"/>
           <p:cNvSpPr/>
           <p:nvPr/>
         </p:nvSpPr>
@@ -6947,7 +6947,7 @@
       </p:sp>
       <p:sp>
         <p:nvSpPr>
-          <p:cNvPr id="6" name="Text 4"/>
+          <p:cNvPr id="7" name="Text 4"/>
           <p:cNvSpPr/>
           <p:nvPr/>
         </p:nvSpPr>
@@ -6989,7 +6989,7 @@
       </p:sp>
       <p:graphicFrame>
         <p:nvGraphicFramePr>
-          <p:cNvPr id="7" name="Chart 0" descr=""/>
+          <p:cNvPr id="8" name="Chart 0" descr=""/>
           <p:cNvGraphicFramePr/>
           <p:nvPr/>
         </p:nvGraphicFramePr>
@@ -7076,7 +7076,7 @@
       </p:sp>
       <p:sp>
         <p:nvSpPr>
-          <p:cNvPr id="3" name="Shape 1"/>
+          <p:cNvPr id="4" name="Shape 1"/>
           <p:cNvSpPr/>
           <p:nvPr/>
         </p:nvSpPr>
@@ -7099,7 +7099,7 @@
       </p:sp>
       <p:sp>
         <p:nvSpPr>
-          <p:cNvPr id="4" name="Text 2"/>
+          <p:cNvPr id="5" name="Text 2"/>
           <p:cNvSpPr/>
           <p:nvPr/>
         </p:nvSpPr>
@@ -7138,7 +7138,7 @@
       </p:sp>
       <p:sp>
         <p:nvSpPr>
-          <p:cNvPr id="5" name="Text 3"/>
+          <p:cNvPr id="6" name="Text 3"/>
           <p:cNvSpPr/>
           <p:nvPr/>
         </p:nvSpPr>
@@ -7180,7 +7180,7 @@
       </p:sp>
       <p:sp>
         <p:nvSpPr>
-          <p:cNvPr id="6" name="Shape 4"/>
+          <p:cNvPr id="7" name="Shape 4"/>
           <p:cNvSpPr/>
           <p:nvPr/>
         </p:nvSpPr>
@@ -7207,7 +7207,7 @@
       </p:sp>
       <p:sp>
         <p:nvSpPr>
-          <p:cNvPr id="7" name="Text 5"/>
+          <p:cNvPr id="8" name="Text 5"/>
           <p:cNvSpPr/>
           <p:nvPr/>
         </p:nvSpPr>
@@ -7246,7 +7246,7 @@
       </p:sp>
       <p:sp>
         <p:nvSpPr>
-          <p:cNvPr id="8" name="Text 6"/>
+          <p:cNvPr id="9" name="Text 6"/>
           <p:cNvSpPr/>
           <p:nvPr/>
         </p:nvSpPr>
@@ -7285,7 +7285,7 @@
       </p:sp>
       <p:sp>
         <p:nvSpPr>
-          <p:cNvPr id="9" name="Shape 7"/>
+          <p:cNvPr id="10" name="Shape 7"/>
           <p:cNvSpPr/>
           <p:nvPr/>
         </p:nvSpPr>
@@ -7307,7 +7307,7 @@
       </p:sp>
       <p:sp>
         <p:nvSpPr>
-          <p:cNvPr id="10" name="Shape 8"/>
+          <p:cNvPr id="11" name="Shape 8"/>
           <p:cNvSpPr/>
           <p:nvPr/>
         </p:nvSpPr>
@@ -7329,7 +7329,7 @@
       </p:sp>
       <p:sp>
         <p:nvSpPr>
-          <p:cNvPr id="11" name="Shape 9"/>
+          <p:cNvPr id="12" name="Shape 9"/>
           <p:cNvSpPr/>
           <p:nvPr/>
         </p:nvSpPr>
@@ -7351,7 +7351,7 @@
       </p:sp>
       <p:sp>
         <p:nvSpPr>
-          <p:cNvPr id="12" name="Shape 10"/>
+          <p:cNvPr id="13" name="Shape 10"/>
           <p:cNvSpPr/>
           <p:nvPr/>
         </p:nvSpPr>
@@ -7373,7 +7373,7 @@
       </p:sp>
       <p:sp>
         <p:nvSpPr>
-          <p:cNvPr id="13" name="Shape 11"/>
+          <p:cNvPr id="14" name="Shape 11"/>
           <p:cNvSpPr/>
           <p:nvPr/>
         </p:nvSpPr>
@@ -7395,7 +7395,7 @@
       </p:sp>
       <p:sp>
         <p:nvSpPr>
-          <p:cNvPr id="14" name="Shape 12"/>
+          <p:cNvPr id="15" name="Shape 12"/>
           <p:cNvSpPr/>
           <p:nvPr/>
         </p:nvSpPr>
@@ -7417,7 +7417,7 @@
       </p:sp>
       <p:sp>
         <p:nvSpPr>
-          <p:cNvPr id="15" name="Shape 13"/>
+          <p:cNvPr id="16" name="Shape 13"/>
           <p:cNvSpPr/>
           <p:nvPr/>
         </p:nvSpPr>
@@ -7439,7 +7439,7 @@
       </p:sp>
       <p:sp>
         <p:nvSpPr>
-          <p:cNvPr id="16" name="Shape 14"/>
+          <p:cNvPr id="17" name="Shape 14"/>
           <p:cNvSpPr/>
           <p:nvPr/>
         </p:nvSpPr>
@@ -7461,7 +7461,7 @@
       </p:sp>
       <p:sp>
         <p:nvSpPr>
-          <p:cNvPr id="17" name="Text 15"/>
+          <p:cNvPr id="18" name="Text 15"/>
           <p:cNvSpPr/>
           <p:nvPr/>
         </p:nvSpPr>
@@ -7500,7 +7500,7 @@
       </p:sp>
       <p:sp>
         <p:nvSpPr>
-          <p:cNvPr id="18" name="Shape 16"/>
+          <p:cNvPr id="19" name="Shape 16"/>
           <p:cNvSpPr/>
           <p:nvPr/>
         </p:nvSpPr>
@@ -7522,7 +7522,7 @@
       </p:sp>
       <p:sp>
         <p:nvSpPr>
-          <p:cNvPr id="19" name="Shape 17"/>
+          <p:cNvPr id="20" name="Shape 17"/>
           <p:cNvSpPr/>
           <p:nvPr/>
         </p:nvSpPr>
@@ -7544,7 +7544,7 @@
       </p:sp>
       <p:sp>
         <p:nvSpPr>
-          <p:cNvPr id="20" name="Shape 18"/>
+          <p:cNvPr id="21" name="Shape 18"/>
           <p:cNvSpPr/>
           <p:nvPr/>
         </p:nvSpPr>
@@ -7566,7 +7566,7 @@
       </p:sp>
       <p:sp>
         <p:nvSpPr>
-          <p:cNvPr id="21" name="Shape 19"/>
+          <p:cNvPr id="22" name="Shape 19"/>
           <p:cNvSpPr/>
           <p:nvPr/>
         </p:nvSpPr>
@@ -7588,7 +7588,7 @@
       </p:sp>
       <p:sp>
         <p:nvSpPr>
-          <p:cNvPr id="22" name="Shape 20"/>
+          <p:cNvPr id="23" name="Shape 20"/>
           <p:cNvSpPr/>
           <p:nvPr/>
         </p:nvSpPr>
@@ -7610,7 +7610,7 @@
       </p:sp>
       <p:sp>
         <p:nvSpPr>
-          <p:cNvPr id="23" name="Shape 21"/>
+          <p:cNvPr id="24" name="Shape 21"/>
           <p:cNvSpPr/>
           <p:nvPr/>
         </p:nvSpPr>
@@ -7632,7 +7632,7 @@
       </p:sp>
       <p:sp>
         <p:nvSpPr>
-          <p:cNvPr id="24" name="Shape 22"/>
+          <p:cNvPr id="25" name="Shape 22"/>
           <p:cNvSpPr/>
           <p:nvPr/>
         </p:nvSpPr>
@@ -7654,7 +7654,7 @@
       </p:sp>
       <p:sp>
         <p:nvSpPr>
-          <p:cNvPr id="25" name="Shape 23"/>
+          <p:cNvPr id="26" name="Shape 23"/>
           <p:cNvSpPr/>
           <p:nvPr/>
         </p:nvSpPr>
@@ -7676,7 +7676,7 @@
       </p:sp>
       <p:sp>
         <p:nvSpPr>
-          <p:cNvPr id="26" name="Text 24"/>
+          <p:cNvPr id="27" name="Text 24"/>
           <p:cNvSpPr/>
           <p:nvPr/>
         </p:nvSpPr>
@@ -7715,7 +7715,7 @@
       </p:sp>
       <p:sp>
         <p:nvSpPr>
-          <p:cNvPr id="27" name="Shape 25"/>
+          <p:cNvPr id="28" name="Shape 25"/>
           <p:cNvSpPr/>
           <p:nvPr/>
         </p:nvSpPr>
@@ -7742,7 +7742,7 @@
       </p:sp>
       <p:sp>
         <p:nvSpPr>
-          <p:cNvPr id="28" name="Text 26"/>
+          <p:cNvPr id="29" name="Text 26"/>
           <p:cNvSpPr/>
           <p:nvPr/>
         </p:nvSpPr>
@@ -7781,7 +7781,7 @@
       </p:sp>
       <p:sp>
         <p:nvSpPr>
-          <p:cNvPr id="29" name="Text 27"/>
+          <p:cNvPr id="30" name="Text 27"/>
           <p:cNvSpPr/>
           <p:nvPr/>
         </p:nvSpPr>
@@ -7820,7 +7820,7 @@
       </p:sp>
       <p:sp>
         <p:nvSpPr>
-          <p:cNvPr id="30" name="Shape 28"/>
+          <p:cNvPr id="31" name="Shape 28"/>
           <p:cNvSpPr/>
           <p:nvPr/>
         </p:nvSpPr>
@@ -7842,7 +7842,7 @@
       </p:sp>
       <p:sp>
         <p:nvSpPr>
-          <p:cNvPr id="31" name="Shape 29"/>
+          <p:cNvPr id="32" name="Shape 29"/>
           <p:cNvSpPr/>
           <p:nvPr/>
         </p:nvSpPr>
@@ -7864,7 +7864,7 @@
       </p:sp>
       <p:sp>
         <p:nvSpPr>
-          <p:cNvPr id="32" name="Shape 30"/>
+          <p:cNvPr id="33" name="Shape 30"/>
           <p:cNvSpPr/>
           <p:nvPr/>
         </p:nvSpPr>
@@ -7886,7 +7886,7 @@
       </p:sp>
       <p:sp>
         <p:nvSpPr>
-          <p:cNvPr id="33" name="Shape 31"/>
+          <p:cNvPr id="34" name="Shape 31"/>
           <p:cNvSpPr/>
           <p:nvPr/>
         </p:nvSpPr>
@@ -7908,7 +7908,7 @@
       </p:sp>
       <p:sp>
         <p:nvSpPr>
-          <p:cNvPr id="34" name="Shape 32"/>
+          <p:cNvPr id="35" name="Shape 32"/>
           <p:cNvSpPr/>
           <p:nvPr/>
         </p:nvSpPr>
@@ -7930,7 +7930,7 @@
       </p:sp>
       <p:sp>
         <p:nvSpPr>
-          <p:cNvPr id="35" name="Shape 33"/>
+          <p:cNvPr id="36" name="Shape 33"/>
           <p:cNvSpPr/>
           <p:nvPr/>
         </p:nvSpPr>
@@ -7952,7 +7952,7 @@
       </p:sp>
       <p:sp>
         <p:nvSpPr>
-          <p:cNvPr id="36" name="Shape 34"/>
+          <p:cNvPr id="37" name="Shape 34"/>
           <p:cNvSpPr/>
           <p:nvPr/>
         </p:nvSpPr>
@@ -7974,7 +7974,7 @@
       </p:sp>
       <p:sp>
         <p:nvSpPr>
-          <p:cNvPr id="37" name="Shape 35"/>
+          <p:cNvPr id="38" name="Shape 35"/>
           <p:cNvSpPr/>
           <p:nvPr/>
         </p:nvSpPr>
@@ -7996,7 +7996,7 @@
       </p:sp>
       <p:sp>
         <p:nvSpPr>
-          <p:cNvPr id="38" name="Text 36"/>
+          <p:cNvPr id="39" name="Text 36"/>
           <p:cNvSpPr/>
           <p:nvPr/>
         </p:nvSpPr>
@@ -8035,7 +8035,7 @@
       </p:sp>
       <p:sp>
         <p:nvSpPr>
-          <p:cNvPr id="39" name="Shape 37"/>
+          <p:cNvPr id="40" name="Shape 37"/>
           <p:cNvSpPr/>
           <p:nvPr/>
         </p:nvSpPr>
@@ -8057,7 +8057,7 @@
       </p:sp>
       <p:sp>
         <p:nvSpPr>
-          <p:cNvPr id="40" name="Shape 38"/>
+          <p:cNvPr id="41" name="Shape 38"/>
           <p:cNvSpPr/>
           <p:nvPr/>
         </p:nvSpPr>
@@ -8079,7 +8079,7 @@
       </p:sp>
       <p:sp>
         <p:nvSpPr>
-          <p:cNvPr id="41" name="Shape 39"/>
+          <p:cNvPr id="42" name="Shape 39"/>
           <p:cNvSpPr/>
           <p:nvPr/>
         </p:nvSpPr>
@@ -8101,7 +8101,7 @@
       </p:sp>
       <p:sp>
         <p:nvSpPr>
-          <p:cNvPr id="42" name="Shape 40"/>
+          <p:cNvPr id="43" name="Shape 40"/>
           <p:cNvSpPr/>
           <p:nvPr/>
         </p:nvSpPr>
@@ -8123,7 +8123,7 @@
       </p:sp>
       <p:sp>
         <p:nvSpPr>
-          <p:cNvPr id="43" name="Shape 41"/>
+          <p:cNvPr id="44" name="Shape 41"/>
           <p:cNvSpPr/>
           <p:nvPr/>
         </p:nvSpPr>
@@ -8145,7 +8145,7 @@
       </p:sp>
       <p:sp>
         <p:nvSpPr>
-          <p:cNvPr id="44" name="Shape 42"/>
+          <p:cNvPr id="45" name="Shape 42"/>
           <p:cNvSpPr/>
           <p:nvPr/>
         </p:nvSpPr>
@@ -8167,7 +8167,7 @@
       </p:sp>
       <p:sp>
         <p:nvSpPr>
-          <p:cNvPr id="45" name="Shape 43"/>
+          <p:cNvPr id="46" name="Shape 43"/>
           <p:cNvSpPr/>
           <p:nvPr/>
         </p:nvSpPr>
@@ -8189,7 +8189,7 @@
       </p:sp>
       <p:sp>
         <p:nvSpPr>
-          <p:cNvPr id="46" name="Shape 44"/>
+          <p:cNvPr id="47" name="Shape 44"/>
           <p:cNvSpPr/>
           <p:nvPr/>
         </p:nvSpPr>
@@ -8211,7 +8211,7 @@
       </p:sp>
       <p:sp>
         <p:nvSpPr>
-          <p:cNvPr id="47" name="Text 45"/>
+          <p:cNvPr id="48" name="Text 45"/>
           <p:cNvSpPr/>
           <p:nvPr/>
         </p:nvSpPr>
@@ -8321,7 +8321,7 @@
       </p:sp>
       <p:sp>
         <p:nvSpPr>
-          <p:cNvPr id="3" name="Shape 1"/>
+          <p:cNvPr id="4" name="Shape 1"/>
           <p:cNvSpPr/>
           <p:nvPr/>
         </p:nvSpPr>
@@ -8344,7 +8344,7 @@
       </p:sp>
       <p:sp>
         <p:nvSpPr>
-          <p:cNvPr id="4" name="Text 2"/>
+          <p:cNvPr id="5" name="Text 2"/>
           <p:cNvSpPr/>
           <p:nvPr/>
         </p:nvSpPr>
@@ -8383,7 +8383,7 @@
       </p:sp>
       <p:sp>
         <p:nvSpPr>
-          <p:cNvPr id="5" name="Text 3"/>
+          <p:cNvPr id="6" name="Text 3"/>
           <p:cNvSpPr/>
           <p:nvPr/>
         </p:nvSpPr>
@@ -8425,7 +8425,7 @@
       </p:sp>
       <p:sp>
         <p:nvSpPr>
-          <p:cNvPr id="6" name="Shape 4"/>
+          <p:cNvPr id="7" name="Shape 4"/>
           <p:cNvSpPr/>
           <p:nvPr/>
         </p:nvSpPr>
@@ -8452,7 +8452,7 @@
       </p:sp>
       <p:sp>
         <p:nvSpPr>
-          <p:cNvPr id="7" name="Text 5"/>
+          <p:cNvPr id="8" name="Text 5"/>
           <p:cNvSpPr/>
           <p:nvPr/>
         </p:nvSpPr>
@@ -8491,7 +8491,7 @@
       </p:sp>
       <p:sp>
         <p:nvSpPr>
-          <p:cNvPr id="8" name="Text 6"/>
+          <p:cNvPr id="9" name="Text 6"/>
           <p:cNvSpPr/>
           <p:nvPr/>
         </p:nvSpPr>
@@ -8530,7 +8530,7 @@
       </p:sp>
       <p:sp>
         <p:nvSpPr>
-          <p:cNvPr id="9" name="Text 7"/>
+          <p:cNvPr id="10" name="Text 7"/>
           <p:cNvSpPr/>
           <p:nvPr/>
         </p:nvSpPr>
@@ -8569,7 +8569,7 @@
       </p:sp>
       <p:sp>
         <p:nvSpPr>
-          <p:cNvPr id="10" name="Shape 8"/>
+          <p:cNvPr id="11" name="Shape 8"/>
           <p:cNvSpPr/>
           <p:nvPr/>
         </p:nvSpPr>
@@ -8596,7 +8596,7 @@
       </p:sp>
       <p:sp>
         <p:nvSpPr>
-          <p:cNvPr id="11" name="Text 9"/>
+          <p:cNvPr id="12" name="Text 9"/>
           <p:cNvSpPr/>
           <p:nvPr/>
         </p:nvSpPr>
@@ -8635,7 +8635,7 @@
       </p:sp>
       <p:sp>
         <p:nvSpPr>
-          <p:cNvPr id="12" name="Text 10"/>
+          <p:cNvPr id="13" name="Text 10"/>
           <p:cNvSpPr/>
           <p:nvPr/>
         </p:nvSpPr>
@@ -8674,7 +8674,7 @@
       </p:sp>
       <p:sp>
         <p:nvSpPr>
-          <p:cNvPr id="13" name="Text 11"/>
+          <p:cNvPr id="14" name="Text 11"/>
           <p:cNvSpPr/>
           <p:nvPr/>
         </p:nvSpPr>
@@ -8713,7 +8713,7 @@
       </p:sp>
       <p:sp>
         <p:nvSpPr>
-          <p:cNvPr id="14" name="Shape 12"/>
+          <p:cNvPr id="15" name="Shape 12"/>
           <p:cNvSpPr/>
           <p:nvPr/>
         </p:nvSpPr>
@@ -8740,7 +8740,7 @@
       </p:sp>
       <p:sp>
         <p:nvSpPr>
-          <p:cNvPr id="15" name="Text 13"/>
+          <p:cNvPr id="16" name="Text 13"/>
           <p:cNvSpPr/>
           <p:nvPr/>
         </p:nvSpPr>
@@ -8779,7 +8779,7 @@
       </p:sp>
       <p:sp>
         <p:nvSpPr>
-          <p:cNvPr id="16" name="Text 14"/>
+          <p:cNvPr id="17" name="Text 14"/>
           <p:cNvSpPr/>
           <p:nvPr/>
         </p:nvSpPr>
@@ -8818,7 +8818,7 @@
       </p:sp>
       <p:sp>
         <p:nvSpPr>
-          <p:cNvPr id="17" name="Text 15"/>
+          <p:cNvPr id="18" name="Text 15"/>
           <p:cNvSpPr/>
           <p:nvPr/>
         </p:nvSpPr>
@@ -8857,7 +8857,7 @@
       </p:sp>
       <p:sp>
         <p:nvSpPr>
-          <p:cNvPr id="18" name="Shape 16"/>
+          <p:cNvPr id="19" name="Shape 16"/>
           <p:cNvSpPr/>
           <p:nvPr/>
         </p:nvSpPr>
@@ -8884,7 +8884,7 @@
       </p:sp>
       <p:sp>
         <p:nvSpPr>
-          <p:cNvPr id="19" name="Text 17"/>
+          <p:cNvPr id="20" name="Text 17"/>
           <p:cNvSpPr/>
           <p:nvPr/>
         </p:nvSpPr>
@@ -8923,7 +8923,7 @@
       </p:sp>
       <p:sp>
         <p:nvSpPr>
-          <p:cNvPr id="20" name="Text 18"/>
+          <p:cNvPr id="21" name="Text 18"/>
           <p:cNvSpPr/>
           <p:nvPr/>
         </p:nvSpPr>
@@ -8962,7 +8962,7 @@
       </p:sp>
       <p:sp>
         <p:nvSpPr>
-          <p:cNvPr id="21" name="Text 19"/>
+          <p:cNvPr id="22" name="Text 19"/>
           <p:cNvSpPr/>
           <p:nvPr/>
         </p:nvSpPr>
@@ -9001,7 +9001,7 @@
       </p:sp>
       <p:sp>
         <p:nvSpPr>
-          <p:cNvPr id="22" name="Shape 20"/>
+          <p:cNvPr id="23" name="Shape 20"/>
           <p:cNvSpPr/>
           <p:nvPr/>
         </p:nvSpPr>
@@ -9028,7 +9028,7 @@
       </p:sp>
       <p:sp>
         <p:nvSpPr>
-          <p:cNvPr id="23" name="Text 21"/>
+          <p:cNvPr id="24" name="Text 21"/>
           <p:cNvSpPr/>
           <p:nvPr/>
         </p:nvSpPr>
@@ -9067,7 +9067,7 @@
       </p:sp>
       <p:sp>
         <p:nvSpPr>
-          <p:cNvPr id="24" name="Text 22"/>
+          <p:cNvPr id="25" name="Text 22"/>
           <p:cNvSpPr/>
           <p:nvPr/>
         </p:nvSpPr>
@@ -9106,7 +9106,7 @@
       </p:sp>
       <p:sp>
         <p:nvSpPr>
-          <p:cNvPr id="25" name="Text 23"/>
+          <p:cNvPr id="26" name="Text 23"/>
           <p:cNvSpPr/>
           <p:nvPr/>
         </p:nvSpPr>
@@ -9145,7 +9145,7 @@
       </p:sp>
       <p:sp>
         <p:nvSpPr>
-          <p:cNvPr id="26" name="Shape 24"/>
+          <p:cNvPr id="27" name="Shape 24"/>
           <p:cNvSpPr/>
           <p:nvPr/>
         </p:nvSpPr>
@@ -9172,7 +9172,7 @@
       </p:sp>
       <p:sp>
         <p:nvSpPr>
-          <p:cNvPr id="27" name="Text 25"/>
+          <p:cNvPr id="28" name="Text 25"/>
           <p:cNvSpPr/>
           <p:nvPr/>
         </p:nvSpPr>
@@ -9211,7 +9211,7 @@
       </p:sp>
       <p:sp>
         <p:nvSpPr>
-          <p:cNvPr id="28" name="Text 26"/>
+          <p:cNvPr id="29" name="Text 26"/>
           <p:cNvSpPr/>
           <p:nvPr/>
         </p:nvSpPr>
@@ -9250,7 +9250,7 @@
       </p:sp>
       <p:sp>
         <p:nvSpPr>
-          <p:cNvPr id="29" name="Text 27"/>
+          <p:cNvPr id="30" name="Text 27"/>
           <p:cNvSpPr/>
           <p:nvPr/>
         </p:nvSpPr>
@@ -9360,7 +9360,7 @@
       </p:sp>
       <p:sp>
         <p:nvSpPr>
-          <p:cNvPr id="3" name="Shape 1"/>
+          <p:cNvPr id="4" name="Shape 1"/>
           <p:cNvSpPr/>
           <p:nvPr/>
         </p:nvSpPr>
@@ -9383,7 +9383,7 @@
       </p:sp>
       <p:sp>
         <p:nvSpPr>
-          <p:cNvPr id="4" name="Text 2"/>
+          <p:cNvPr id="5" name="Text 2"/>
           <p:cNvSpPr/>
           <p:nvPr/>
         </p:nvSpPr>
@@ -9422,7 +9422,7 @@
       </p:sp>
       <p:sp>
         <p:nvSpPr>
-          <p:cNvPr id="5" name="Text 3"/>
+          <p:cNvPr id="6" name="Text 3"/>
           <p:cNvSpPr/>
           <p:nvPr/>
         </p:nvSpPr>
@@ -9464,7 +9464,7 @@
       </p:sp>
       <p:pic>
         <p:nvPicPr>
-          <p:cNvPr id="6" name="Image 0" descr="preencoded.png">    </p:cNvPr>
+          <p:cNvPr id="7" name="Image 0" descr="preencoded.png">    </p:cNvPr>
           <p:cNvPicPr>
             <a:picLocks noChangeAspect="1"/>
           </p:cNvPicPr>
@@ -9558,7 +9558,7 @@
       </p:sp>
       <p:sp>
         <p:nvSpPr>
-          <p:cNvPr id="3" name="Shape 1"/>
+          <p:cNvPr id="4" name="Shape 1"/>
           <p:cNvSpPr/>
           <p:nvPr/>
         </p:nvSpPr>
@@ -9581,7 +9581,7 @@
       </p:sp>
       <p:sp>
         <p:nvSpPr>
-          <p:cNvPr id="4" name="Text 2"/>
+          <p:cNvPr id="5" name="Text 2"/>
           <p:cNvSpPr/>
           <p:nvPr/>
         </p:nvSpPr>
@@ -9620,7 +9620,7 @@
       </p:sp>
       <p:sp>
         <p:nvSpPr>
-          <p:cNvPr id="5" name="Text 3"/>
+          <p:cNvPr id="6" name="Text 3"/>
           <p:cNvSpPr/>
           <p:nvPr/>
         </p:nvSpPr>
@@ -9662,7 +9662,7 @@
       </p:sp>
       <p:sp>
         <p:nvSpPr>
-          <p:cNvPr id="6" name="Shape 4"/>
+          <p:cNvPr id="7" name="Shape 4"/>
           <p:cNvSpPr/>
           <p:nvPr/>
         </p:nvSpPr>
@@ -9689,7 +9689,7 @@
       </p:sp>
       <p:sp>
         <p:nvSpPr>
-          <p:cNvPr id="7" name="Text 5"/>
+          <p:cNvPr id="8" name="Text 5"/>
           <p:cNvSpPr/>
           <p:nvPr/>
         </p:nvSpPr>
@@ -9728,7 +9728,7 @@
       </p:sp>
       <p:sp>
         <p:nvSpPr>
-          <p:cNvPr id="8" name="Text 6"/>
+          <p:cNvPr id="9" name="Text 6"/>
           <p:cNvSpPr/>
           <p:nvPr/>
         </p:nvSpPr>
@@ -9784,7 +9784,7 @@
       </p:sp>
       <p:sp>
         <p:nvSpPr>
-          <p:cNvPr id="9" name="Text 7"/>
+          <p:cNvPr id="10" name="Text 7"/>
           <p:cNvSpPr/>
           <p:nvPr/>
         </p:nvSpPr>
@@ -9840,7 +9840,7 @@
       </p:sp>
       <p:sp>
         <p:nvSpPr>
-          <p:cNvPr id="10" name="Text 8"/>
+          <p:cNvPr id="11" name="Text 8"/>
           <p:cNvSpPr/>
           <p:nvPr/>
         </p:nvSpPr>
@@ -9879,7 +9879,7 @@
       </p:sp>
       <p:sp>
         <p:nvSpPr>
-          <p:cNvPr id="11" name="Shape 9"/>
+          <p:cNvPr id="12" name="Shape 9"/>
           <p:cNvSpPr/>
           <p:nvPr/>
         </p:nvSpPr>
@@ -9906,7 +9906,7 @@
       </p:sp>
       <p:sp>
         <p:nvSpPr>
-          <p:cNvPr id="12" name="Text 10"/>
+          <p:cNvPr id="13" name="Text 10"/>
           <p:cNvSpPr/>
           <p:nvPr/>
         </p:nvSpPr>
@@ -9945,7 +9945,7 @@
       </p:sp>
       <p:sp>
         <p:nvSpPr>
-          <p:cNvPr id="13" name="Text 11"/>
+          <p:cNvPr id="14" name="Text 11"/>
           <p:cNvSpPr/>
           <p:nvPr/>
         </p:nvSpPr>
@@ -10001,7 +10001,7 @@
       </p:sp>
       <p:sp>
         <p:nvSpPr>
-          <p:cNvPr id="14" name="Shape 12"/>
+          <p:cNvPr id="15" name="Shape 12"/>
           <p:cNvSpPr/>
           <p:nvPr/>
         </p:nvSpPr>
@@ -10028,7 +10028,7 @@
       </p:sp>
       <p:sp>
         <p:nvSpPr>
-          <p:cNvPr id="15" name="Text 13"/>
+          <p:cNvPr id="16" name="Text 13"/>
           <p:cNvSpPr/>
           <p:nvPr/>
         </p:nvSpPr>
@@ -10067,7 +10067,7 @@
       </p:sp>
       <p:sp>
         <p:nvSpPr>
-          <p:cNvPr id="16" name="Shape 14"/>
+          <p:cNvPr id="17" name="Shape 14"/>
           <p:cNvSpPr/>
           <p:nvPr/>
         </p:nvSpPr>
@@ -10094,7 +10094,7 @@
       </p:sp>
       <p:sp>
         <p:nvSpPr>
-          <p:cNvPr id="17" name="Text 15"/>
+          <p:cNvPr id="18" name="Text 15"/>
           <p:cNvSpPr/>
           <p:nvPr/>
         </p:nvSpPr>
@@ -10133,7 +10133,7 @@
       </p:sp>
       <p:sp>
         <p:nvSpPr>
-          <p:cNvPr id="18" name="Shape 16"/>
+          <p:cNvPr id="19" name="Shape 16"/>
           <p:cNvSpPr/>
           <p:nvPr/>
         </p:nvSpPr>
@@ -10160,7 +10160,7 @@
       </p:sp>
       <p:sp>
         <p:nvSpPr>
-          <p:cNvPr id="19" name="Text 17"/>
+          <p:cNvPr id="20" name="Text 17"/>
           <p:cNvSpPr/>
           <p:nvPr/>
         </p:nvSpPr>
@@ -10270,7 +10270,7 @@
       </p:sp>
       <p:sp>
         <p:nvSpPr>
-          <p:cNvPr id="3" name="Shape 1"/>
+          <p:cNvPr id="4" name="Shape 1"/>
           <p:cNvSpPr/>
           <p:nvPr/>
         </p:nvSpPr>
@@ -10293,7 +10293,7 @@
       </p:sp>
       <p:sp>
         <p:nvSpPr>
-          <p:cNvPr id="4" name="Text 2"/>
+          <p:cNvPr id="5" name="Text 2"/>
           <p:cNvSpPr/>
           <p:nvPr/>
         </p:nvSpPr>
@@ -10332,7 +10332,7 @@
       </p:sp>
       <p:sp>
         <p:nvSpPr>
-          <p:cNvPr id="5" name="Text 3"/>
+          <p:cNvPr id="6" name="Text 3"/>
           <p:cNvSpPr/>
           <p:nvPr/>
         </p:nvSpPr>
@@ -10374,7 +10374,7 @@
       </p:sp>
       <p:sp>
         <p:nvSpPr>
-          <p:cNvPr id="6" name="Shape 4"/>
+          <p:cNvPr id="7" name="Shape 4"/>
           <p:cNvSpPr/>
           <p:nvPr/>
         </p:nvSpPr>
@@ -10401,7 +10401,7 @@
       </p:sp>
       <p:sp>
         <p:nvSpPr>
-          <p:cNvPr id="7" name="Shape 5"/>
+          <p:cNvPr id="8" name="Shape 5"/>
           <p:cNvSpPr/>
           <p:nvPr/>
         </p:nvSpPr>
@@ -10421,7 +10421,7 @@
       </p:sp>
       <p:sp>
         <p:nvSpPr>
-          <p:cNvPr id="8" name="Text 6"/>
+          <p:cNvPr id="9" name="Text 6"/>
           <p:cNvSpPr/>
           <p:nvPr/>
         </p:nvSpPr>
@@ -10460,7 +10460,7 @@
       </p:sp>
       <p:sp>
         <p:nvSpPr>
-          <p:cNvPr id="9" name="Text 7"/>
+          <p:cNvPr id="10" name="Text 7"/>
           <p:cNvSpPr/>
           <p:nvPr/>
         </p:nvSpPr>
@@ -10499,7 +10499,7 @@
       </p:sp>
       <p:sp>
         <p:nvSpPr>
-          <p:cNvPr id="10" name="Shape 8"/>
+          <p:cNvPr id="11" name="Shape 8"/>
           <p:cNvSpPr/>
           <p:nvPr/>
         </p:nvSpPr>
@@ -10526,7 +10526,7 @@
       </p:sp>
       <p:sp>
         <p:nvSpPr>
-          <p:cNvPr id="11" name="Shape 9"/>
+          <p:cNvPr id="12" name="Shape 9"/>
           <p:cNvSpPr/>
           <p:nvPr/>
         </p:nvSpPr>
@@ -10546,7 +10546,7 @@
       </p:sp>
       <p:sp>
         <p:nvSpPr>
-          <p:cNvPr id="12" name="Text 10"/>
+          <p:cNvPr id="13" name="Text 10"/>
           <p:cNvSpPr/>
           <p:nvPr/>
         </p:nvSpPr>
@@ -10585,7 +10585,7 @@
       </p:sp>
       <p:sp>
         <p:nvSpPr>
-          <p:cNvPr id="13" name="Text 11"/>
+          <p:cNvPr id="14" name="Text 11"/>
           <p:cNvSpPr/>
           <p:nvPr/>
         </p:nvSpPr>
@@ -10624,7 +10624,7 @@
       </p:sp>
       <p:sp>
         <p:nvSpPr>
-          <p:cNvPr id="14" name="Shape 12"/>
+          <p:cNvPr id="15" name="Shape 12"/>
           <p:cNvSpPr/>
           <p:nvPr/>
         </p:nvSpPr>
@@ -10651,7 +10651,7 @@
       </p:sp>
       <p:sp>
         <p:nvSpPr>
-          <p:cNvPr id="15" name="Shape 13"/>
+          <p:cNvPr id="16" name="Shape 13"/>
           <p:cNvSpPr/>
           <p:nvPr/>
         </p:nvSpPr>
@@ -10671,7 +10671,7 @@
       </p:sp>
       <p:sp>
         <p:nvSpPr>
-          <p:cNvPr id="16" name="Text 14"/>
+          <p:cNvPr id="17" name="Text 14"/>
           <p:cNvSpPr/>
           <p:nvPr/>
         </p:nvSpPr>
@@ -10710,7 +10710,7 @@
       </p:sp>
       <p:sp>
         <p:nvSpPr>
-          <p:cNvPr id="17" name="Text 15"/>
+          <p:cNvPr id="18" name="Text 15"/>
           <p:cNvSpPr/>
           <p:nvPr/>
         </p:nvSpPr>
@@ -10749,7 +10749,7 @@
       </p:sp>
       <p:sp>
         <p:nvSpPr>
-          <p:cNvPr id="18" name="Shape 16"/>
+          <p:cNvPr id="19" name="Shape 16"/>
           <p:cNvSpPr/>
           <p:nvPr/>
         </p:nvSpPr>
@@ -10776,7 +10776,7 @@
       </p:sp>
       <p:sp>
         <p:nvSpPr>
-          <p:cNvPr id="19" name="Shape 17"/>
+          <p:cNvPr id="20" name="Shape 17"/>
           <p:cNvSpPr/>
           <p:nvPr/>
         </p:nvSpPr>
@@ -10796,7 +10796,7 @@
       </p:sp>
       <p:sp>
         <p:nvSpPr>
-          <p:cNvPr id="20" name="Text 18"/>
+          <p:cNvPr id="21" name="Text 18"/>
           <p:cNvSpPr/>
           <p:nvPr/>
         </p:nvSpPr>
@@ -10835,7 +10835,7 @@
       </p:sp>
       <p:sp>
         <p:nvSpPr>
-          <p:cNvPr id="21" name="Text 19"/>
+          <p:cNvPr id="22" name="Text 19"/>
           <p:cNvSpPr/>
           <p:nvPr/>
         </p:nvSpPr>
@@ -10874,7 +10874,7 @@
       </p:sp>
       <p:sp>
         <p:nvSpPr>
-          <p:cNvPr id="22" name="Text 20"/>
+          <p:cNvPr id="23" name="Text 20"/>
           <p:cNvSpPr/>
           <p:nvPr/>
         </p:nvSpPr>
@@ -10913,7 +10913,7 @@
       </p:sp>
       <p:graphicFrame>
         <p:nvGraphicFramePr>
-          <p:cNvPr id="23" name="Chart 0" descr=""/>
+          <p:cNvPr id="24" name="Chart 0" descr=""/>
           <p:cNvGraphicFramePr/>
           <p:nvPr/>
         </p:nvGraphicFramePr>
@@ -11000,7 +11000,7 @@
       </p:sp>
       <p:sp>
         <p:nvSpPr>
-          <p:cNvPr id="3" name="Shape 1"/>
+          <p:cNvPr id="4" name="Shape 1"/>
           <p:cNvSpPr/>
           <p:nvPr/>
         </p:nvSpPr>
@@ -11023,7 +11023,7 @@
       </p:sp>
       <p:sp>
         <p:nvSpPr>
-          <p:cNvPr id="4" name="Text 2"/>
+          <p:cNvPr id="5" name="Text 2"/>
           <p:cNvSpPr/>
           <p:nvPr/>
         </p:nvSpPr>
@@ -11062,7 +11062,7 @@
       </p:sp>
       <p:sp>
         <p:nvSpPr>
-          <p:cNvPr id="5" name="Text 3"/>
+          <p:cNvPr id="6" name="Text 3"/>
           <p:cNvSpPr/>
           <p:nvPr/>
         </p:nvSpPr>
@@ -13569,7 +13569,7 @@
       </p:sp>
       <p:sp>
         <p:nvSpPr>
-          <p:cNvPr id="3" name="Shape 1"/>
+          <p:cNvPr id="4" name="Shape 1"/>
           <p:cNvSpPr/>
           <p:nvPr/>
         </p:nvSpPr>
@@ -13592,7 +13592,7 @@
       </p:sp>
       <p:sp>
         <p:nvSpPr>
-          <p:cNvPr id="4" name="Text 2"/>
+          <p:cNvPr id="5" name="Text 2"/>
           <p:cNvSpPr/>
           <p:nvPr/>
         </p:nvSpPr>
@@ -13631,7 +13631,7 @@
       </p:sp>
       <p:sp>
         <p:nvSpPr>
-          <p:cNvPr id="5" name="Text 3"/>
+          <p:cNvPr id="6" name="Text 3"/>
           <p:cNvSpPr/>
           <p:nvPr/>
         </p:nvSpPr>
@@ -13673,7 +13673,7 @@
       </p:sp>
       <p:sp>
         <p:nvSpPr>
-          <p:cNvPr id="6" name="Shape 4"/>
+          <p:cNvPr id="7" name="Shape 4"/>
           <p:cNvSpPr/>
           <p:nvPr/>
         </p:nvSpPr>
@@ -13700,7 +13700,7 @@
       </p:sp>
       <p:sp>
         <p:nvSpPr>
-          <p:cNvPr id="7" name="Text 5"/>
+          <p:cNvPr id="8" name="Text 5"/>
           <p:cNvSpPr/>
           <p:nvPr/>
         </p:nvSpPr>
@@ -13739,7 +13739,7 @@
       </p:sp>
       <p:sp>
         <p:nvSpPr>
-          <p:cNvPr id="8" name="Text 6"/>
+          <p:cNvPr id="9" name="Text 6"/>
           <p:cNvSpPr/>
           <p:nvPr/>
         </p:nvSpPr>
@@ -13778,7 +13778,7 @@
       </p:sp>
       <p:sp>
         <p:nvSpPr>
-          <p:cNvPr id="9" name="Text 7"/>
+          <p:cNvPr id="10" name="Text 7"/>
           <p:cNvSpPr/>
           <p:nvPr/>
         </p:nvSpPr>
@@ -13817,7 +13817,7 @@
       </p:sp>
       <p:sp>
         <p:nvSpPr>
-          <p:cNvPr id="10" name="Text 8"/>
+          <p:cNvPr id="11" name="Text 8"/>
           <p:cNvSpPr/>
           <p:nvPr/>
         </p:nvSpPr>
@@ -13856,7 +13856,7 @@
       </p:sp>
       <p:sp>
         <p:nvSpPr>
-          <p:cNvPr id="11" name="Text 9"/>
+          <p:cNvPr id="12" name="Text 9"/>
           <p:cNvSpPr/>
           <p:nvPr/>
         </p:nvSpPr>
@@ -13895,7 +13895,7 @@
       </p:sp>
       <p:sp>
         <p:nvSpPr>
-          <p:cNvPr id="12" name="Text 10"/>
+          <p:cNvPr id="13" name="Text 10"/>
           <p:cNvSpPr/>
           <p:nvPr/>
         </p:nvSpPr>
@@ -13934,7 +13934,7 @@
       </p:sp>
       <p:sp>
         <p:nvSpPr>
-          <p:cNvPr id="13" name="Text 11"/>
+          <p:cNvPr id="14" name="Text 11"/>
           <p:cNvSpPr/>
           <p:nvPr/>
         </p:nvSpPr>
@@ -13973,7 +13973,7 @@
       </p:sp>
       <p:sp>
         <p:nvSpPr>
-          <p:cNvPr id="14" name="Text 12"/>
+          <p:cNvPr id="15" name="Text 12"/>
           <p:cNvSpPr/>
           <p:nvPr/>
         </p:nvSpPr>
@@ -14026,7 +14026,7 @@
       </p:sp>
       <p:sp>
         <p:nvSpPr>
-          <p:cNvPr id="15" name="Shape 13"/>
+          <p:cNvPr id="16" name="Shape 13"/>
           <p:cNvSpPr/>
           <p:nvPr/>
         </p:nvSpPr>
@@ -14053,7 +14053,7 @@
       </p:sp>
       <p:sp>
         <p:nvSpPr>
-          <p:cNvPr id="16" name="Text 14"/>
+          <p:cNvPr id="17" name="Text 14"/>
           <p:cNvSpPr/>
           <p:nvPr/>
         </p:nvSpPr>
@@ -14092,7 +14092,7 @@
       </p:sp>
       <p:sp>
         <p:nvSpPr>
-          <p:cNvPr id="17" name="Text 15"/>
+          <p:cNvPr id="18" name="Text 15"/>
           <p:cNvSpPr/>
           <p:nvPr/>
         </p:nvSpPr>
@@ -14131,7 +14131,7 @@
       </p:sp>
       <p:sp>
         <p:nvSpPr>
-          <p:cNvPr id="18" name="Text 16"/>
+          <p:cNvPr id="19" name="Text 16"/>
           <p:cNvSpPr/>
           <p:nvPr/>
         </p:nvSpPr>
@@ -14170,7 +14170,7 @@
       </p:sp>
       <p:sp>
         <p:nvSpPr>
-          <p:cNvPr id="19" name="Text 17"/>
+          <p:cNvPr id="20" name="Text 17"/>
           <p:cNvSpPr/>
           <p:nvPr/>
         </p:nvSpPr>
@@ -14209,7 +14209,7 @@
       </p:sp>
       <p:sp>
         <p:nvSpPr>
-          <p:cNvPr id="20" name="Text 18"/>
+          <p:cNvPr id="21" name="Text 18"/>
           <p:cNvSpPr/>
           <p:nvPr/>
         </p:nvSpPr>
@@ -14248,7 +14248,7 @@
       </p:sp>
       <p:sp>
         <p:nvSpPr>
-          <p:cNvPr id="21" name="Text 19"/>
+          <p:cNvPr id="22" name="Text 19"/>
           <p:cNvSpPr/>
           <p:nvPr/>
         </p:nvSpPr>
@@ -14287,7 +14287,7 @@
       </p:sp>
       <p:sp>
         <p:nvSpPr>
-          <p:cNvPr id="22" name="Text 20"/>
+          <p:cNvPr id="23" name="Text 20"/>
           <p:cNvSpPr/>
           <p:nvPr/>
         </p:nvSpPr>
@@ -14326,7 +14326,7 @@
       </p:sp>
       <p:sp>
         <p:nvSpPr>
-          <p:cNvPr id="23" name="Text 21"/>
+          <p:cNvPr id="24" name="Text 21"/>
           <p:cNvSpPr/>
           <p:nvPr/>
         </p:nvSpPr>

</xml_diff>

<commit_message>
fix(pptx): visual bugs found by actually rendering it in LibreOffice
Installed LibreOffice portably (no root) to render every slide to PNG
and check it for real, not just structurally. Found and fixed:
- Motivation bar chart showed "2" for every value — added an explicit
  0.00 number format so 2.30 / 2.30 / 2.43 render correctly
- The train/test patient squares on "The problem" slide had no
  labels, unlike the website's version — added P1/P2/... text so the
  leak is legible without the live page's interactivity
- Consolas (Windows-only) made several long URL/email strings wrap
  mid-word with a visible gap when LibreOffice substituted a
  differently-metriced font; switched to Courier New (universally
  available) and widened the affected text boxes for margin

Re-rendered after each fix and visually confirmed all 14 slides.
</commit_message>
<xml_diff>
--- a/Mini-DDSM-CSDE2026-Presentation.pptx
+++ b/Mini-DDSM-CSDE2026-Presentation.pptx
@@ -154,7 +154,7 @@
           </c:spPr>
           <c:invertIfNegative val="0"/>
           <c:dLbls>
-            <c:numFmt formatCode="#,##0" sourceLinked="0"/>
+            <c:numFmt formatCode="0.00" sourceLinked="0"/>
             <c:txPr>
               <a:bodyPr/>
               <a:lstStyle/>
@@ -249,7 +249,7 @@
           </c:val>
         </c:ser>
         <c:dLbls>
-          <c:numFmt formatCode="#,##0" sourceLinked="0"/>
+          <c:numFmt formatCode="0.00" sourceLinked="0"/>
           <c:txPr>
             <a:bodyPr/>
             <a:lstStyle/>
@@ -3343,9 +3343,9 @@
                 <a:solidFill>
                   <a:srgbClr val="1F2A52"/>
                 </a:solidFill>
-                <a:latin typeface="Consolas" pitchFamily="34" charset="0"/>
-                <a:ea typeface="Consolas" pitchFamily="34" charset="-122"/>
-                <a:cs typeface="Consolas" pitchFamily="34" charset="-120"/>
+                <a:latin typeface="Courier New" pitchFamily="34" charset="0"/>
+                <a:ea typeface="Courier New" pitchFamily="34" charset="-122"/>
+                <a:cs typeface="Courier New" pitchFamily="34" charset="-120"/>
               </a:rPr>
               <a:t>0.891</a:t>
             </a:r>
@@ -3448,9 +3448,9 @@
                 <a:solidFill>
                   <a:srgbClr val="1F2A52"/>
                 </a:solidFill>
-                <a:latin typeface="Consolas" pitchFamily="34" charset="0"/>
-                <a:ea typeface="Consolas" pitchFamily="34" charset="-122"/>
-                <a:cs typeface="Consolas" pitchFamily="34" charset="-120"/>
+                <a:latin typeface="Courier New" pitchFamily="34" charset="0"/>
+                <a:ea typeface="Courier New" pitchFamily="34" charset="-122"/>
+                <a:cs typeface="Courier New" pitchFamily="34" charset="-120"/>
               </a:rPr>
               <a:t>2,417</a:t>
             </a:r>
@@ -3553,9 +3553,9 @@
                 <a:solidFill>
                   <a:srgbClr val="1F2A52"/>
                 </a:solidFill>
-                <a:latin typeface="Consolas" pitchFamily="34" charset="0"/>
-                <a:ea typeface="Consolas" pitchFamily="34" charset="-122"/>
-                <a:cs typeface="Consolas" pitchFamily="34" charset="-120"/>
+                <a:latin typeface="Courier New" pitchFamily="34" charset="0"/>
+                <a:ea typeface="Courier New" pitchFamily="34" charset="-122"/>
+                <a:cs typeface="Courier New" pitchFamily="34" charset="-120"/>
               </a:rPr>
               <a:t>0</a:t>
             </a:r>
@@ -6141,8 +6141,8 @@
         </p:nvSpPr>
         <p:spPr>
           <a:xfrm>
-            <a:off x="9784080" y="3246120"/>
-            <a:ext cx="1645920" cy="228600"/>
+            <a:off x="9692640" y="3246120"/>
+            <a:ext cx="1828800" cy="228600"/>
           </a:xfrm>
           <a:prstGeom prst="rect">
             <a:avLst/>
@@ -6158,17 +6158,17 @@
               <a:buNone/>
             </a:pPr>
             <a:r>
-              <a:rPr lang="en-US" sz="750" dirty="0">
+              <a:rPr lang="en-US" sz="700" dirty="0">
                 <a:solidFill>
                   <a:srgbClr val="3D4873"/>
                 </a:solidFill>
-                <a:latin typeface="Consolas" pitchFamily="34" charset="0"/>
-                <a:ea typeface="Consolas" pitchFamily="34" charset="-122"/>
-                <a:cs typeface="Consolas" pitchFamily="34" charset="-120"/>
+                <a:latin typeface="Courier New" pitchFamily="34" charset="0"/>
+                <a:ea typeface="Courier New" pitchFamily="34" charset="-122"/>
+                <a:cs typeface="Courier New" pitchFamily="34" charset="-120"/>
               </a:rPr>
               <a:t>mini-ddsm-csde2026.vercel.app</a:t>
             </a:r>
-            <a:endParaRPr lang="en-US" sz="750" dirty="0"/>
+            <a:endParaRPr lang="en-US" sz="700" dirty="0"/>
           </a:p>
         </p:txBody>
       </p:sp>
@@ -6529,8 +6529,8 @@
         </p:nvSpPr>
         <p:spPr>
           <a:xfrm>
-            <a:off x="914400" y="4315968"/>
-            <a:ext cx="2834640" cy="411480"/>
+            <a:off x="822960" y="4315968"/>
+            <a:ext cx="3017520" cy="411480"/>
           </a:xfrm>
           <a:prstGeom prst="rect">
             <a:avLst/>
@@ -6546,17 +6546,17 @@
               <a:buNone/>
             </a:pPr>
             <a:r>
-              <a:rPr lang="en-US" sz="1100" dirty="0">
+              <a:rPr lang="en-US" sz="1000" dirty="0">
                 <a:solidFill>
                   <a:srgbClr val="3D4873"/>
                 </a:solidFill>
-                <a:latin typeface="Consolas" pitchFamily="34" charset="0"/>
-                <a:ea typeface="Consolas" pitchFamily="34" charset="-122"/>
-                <a:cs typeface="Consolas" pitchFamily="34" charset="-120"/>
+                <a:latin typeface="Courier New" pitchFamily="34" charset="0"/>
+                <a:ea typeface="Courier New" pitchFamily="34" charset="-122"/>
+                <a:cs typeface="Courier New" pitchFamily="34" charset="-120"/>
               </a:rPr>
               <a:t>sheikhnoorabdullah02@gmail.com</a:t>
             </a:r>
-            <a:endParaRPr lang="en-US" sz="1100" dirty="0"/>
+            <a:endParaRPr lang="en-US" sz="1000" dirty="0"/>
           </a:p>
         </p:txBody>
       </p:sp>
@@ -6634,8 +6634,8 @@
         </p:nvSpPr>
         <p:spPr>
           <a:xfrm>
-            <a:off x="4480560" y="4315968"/>
-            <a:ext cx="2834640" cy="411480"/>
+            <a:off x="4389120" y="4315968"/>
+            <a:ext cx="3017520" cy="411480"/>
           </a:xfrm>
           <a:prstGeom prst="rect">
             <a:avLst/>
@@ -6651,17 +6651,17 @@
               <a:buNone/>
             </a:pPr>
             <a:r>
-              <a:rPr lang="en-US" sz="1100" dirty="0">
+              <a:rPr lang="en-US" sz="1000" dirty="0">
                 <a:solidFill>
                   <a:srgbClr val="3D4873"/>
                 </a:solidFill>
-                <a:latin typeface="Consolas" pitchFamily="34" charset="0"/>
-                <a:ea typeface="Consolas" pitchFamily="34" charset="-122"/>
-                <a:cs typeface="Consolas" pitchFamily="34" charset="-120"/>
+                <a:latin typeface="Courier New" pitchFamily="34" charset="0"/>
+                <a:ea typeface="Courier New" pitchFamily="34" charset="-122"/>
+                <a:cs typeface="Courier New" pitchFamily="34" charset="-120"/>
               </a:rPr>
               <a:t>github.com/NoorAbdullah02/MINI_DDSM</a:t>
             </a:r>
-            <a:endParaRPr lang="en-US" sz="1100" dirty="0"/>
+            <a:endParaRPr lang="en-US" sz="1000" dirty="0"/>
           </a:p>
         </p:txBody>
       </p:sp>
@@ -6739,8 +6739,8 @@
         </p:nvSpPr>
         <p:spPr>
           <a:xfrm>
-            <a:off x="8046720" y="4315968"/>
-            <a:ext cx="2834640" cy="411480"/>
+            <a:off x="7955280" y="4315968"/>
+            <a:ext cx="3017520" cy="411480"/>
           </a:xfrm>
           <a:prstGeom prst="rect">
             <a:avLst/>
@@ -6756,17 +6756,17 @@
               <a:buNone/>
             </a:pPr>
             <a:r>
-              <a:rPr lang="en-US" sz="1100" dirty="0">
+              <a:rPr lang="en-US" sz="1000" dirty="0">
                 <a:solidFill>
                   <a:srgbClr val="3D4873"/>
                 </a:solidFill>
-                <a:latin typeface="Consolas" pitchFamily="34" charset="0"/>
-                <a:ea typeface="Consolas" pitchFamily="34" charset="-122"/>
-                <a:cs typeface="Consolas" pitchFamily="34" charset="-120"/>
+                <a:latin typeface="Courier New" pitchFamily="34" charset="0"/>
+                <a:ea typeface="Courier New" pitchFamily="34" charset="-122"/>
+                <a:cs typeface="Courier New" pitchFamily="34" charset="-120"/>
               </a:rPr>
               <a:t>mini-ddsm-csde2026.vercel.app</a:t>
             </a:r>
-            <a:endParaRPr lang="en-US" sz="1100" dirty="0"/>
+            <a:endParaRPr lang="en-US" sz="1000" dirty="0"/>
           </a:p>
         </p:txBody>
       </p:sp>
@@ -7307,7 +7307,46 @@
       </p:sp>
       <p:sp>
         <p:nvSpPr>
-          <p:cNvPr id="11" name="Shape 8"/>
+          <p:cNvPr id="11" name="Text 8"/>
+          <p:cNvSpPr/>
+          <p:nvPr/>
+        </p:nvSpPr>
+        <p:spPr>
+          <a:xfrm>
+            <a:off x="960120" y="3337560"/>
+            <a:ext cx="329184" cy="329184"/>
+          </a:xfrm>
+          <a:prstGeom prst="rect">
+            <a:avLst/>
+          </a:prstGeom>
+          <a:noFill/>
+          <a:ln/>
+        </p:spPr>
+        <p:txBody>
+          <a:bodyPr wrap="square" rtlCol="0" anchor="ctr"/>
+          <a:lstStyle/>
+          <a:p>
+            <a:pPr algn="ctr" indent="0" marL="0">
+              <a:buNone/>
+            </a:pPr>
+            <a:r>
+              <a:rPr lang="en-US" sz="800" b="1" dirty="0">
+                <a:solidFill>
+                  <a:srgbClr val="FFFFFF"/>
+                </a:solidFill>
+                <a:latin typeface="Calibri" pitchFamily="34" charset="0"/>
+                <a:ea typeface="Calibri" pitchFamily="34" charset="-122"/>
+                <a:cs typeface="Calibri" pitchFamily="34" charset="-120"/>
+              </a:rPr>
+              <a:t>P1</a:t>
+            </a:r>
+            <a:endParaRPr lang="en-US" sz="800" dirty="0"/>
+          </a:p>
+        </p:txBody>
+      </p:sp>
+      <p:sp>
+        <p:nvSpPr>
+          <p:cNvPr id="12" name="Shape 9"/>
           <p:cNvSpPr/>
           <p:nvPr/>
         </p:nvSpPr>
@@ -7329,7 +7368,46 @@
       </p:sp>
       <p:sp>
         <p:nvSpPr>
-          <p:cNvPr id="12" name="Shape 9"/>
+          <p:cNvPr id="13" name="Text 10"/>
+          <p:cNvSpPr/>
+          <p:nvPr/>
+        </p:nvSpPr>
+        <p:spPr>
+          <a:xfrm>
+            <a:off x="1344168" y="3337560"/>
+            <a:ext cx="329184" cy="329184"/>
+          </a:xfrm>
+          <a:prstGeom prst="rect">
+            <a:avLst/>
+          </a:prstGeom>
+          <a:noFill/>
+          <a:ln/>
+        </p:spPr>
+        <p:txBody>
+          <a:bodyPr wrap="square" rtlCol="0" anchor="ctr"/>
+          <a:lstStyle/>
+          <a:p>
+            <a:pPr algn="ctr" indent="0" marL="0">
+              <a:buNone/>
+            </a:pPr>
+            <a:r>
+              <a:rPr lang="en-US" sz="800" b="1" dirty="0">
+                <a:solidFill>
+                  <a:srgbClr val="FFFFFF"/>
+                </a:solidFill>
+                <a:latin typeface="Calibri" pitchFamily="34" charset="0"/>
+                <a:ea typeface="Calibri" pitchFamily="34" charset="-122"/>
+                <a:cs typeface="Calibri" pitchFamily="34" charset="-120"/>
+              </a:rPr>
+              <a:t>P2</a:t>
+            </a:r>
+            <a:endParaRPr lang="en-US" sz="800" dirty="0"/>
+          </a:p>
+        </p:txBody>
+      </p:sp>
+      <p:sp>
+        <p:nvSpPr>
+          <p:cNvPr id="14" name="Shape 11"/>
           <p:cNvSpPr/>
           <p:nvPr/>
         </p:nvSpPr>
@@ -7351,7 +7429,46 @@
       </p:sp>
       <p:sp>
         <p:nvSpPr>
-          <p:cNvPr id="13" name="Shape 10"/>
+          <p:cNvPr id="15" name="Text 12"/>
+          <p:cNvSpPr/>
+          <p:nvPr/>
+        </p:nvSpPr>
+        <p:spPr>
+          <a:xfrm>
+            <a:off x="1728216" y="3337560"/>
+            <a:ext cx="329184" cy="329184"/>
+          </a:xfrm>
+          <a:prstGeom prst="rect">
+            <a:avLst/>
+          </a:prstGeom>
+          <a:noFill/>
+          <a:ln/>
+        </p:spPr>
+        <p:txBody>
+          <a:bodyPr wrap="square" rtlCol="0" anchor="ctr"/>
+          <a:lstStyle/>
+          <a:p>
+            <a:pPr algn="ctr" indent="0" marL="0">
+              <a:buNone/>
+            </a:pPr>
+            <a:r>
+              <a:rPr lang="en-US" sz="800" b="1" dirty="0">
+                <a:solidFill>
+                  <a:srgbClr val="FFFFFF"/>
+                </a:solidFill>
+                <a:latin typeface="Calibri" pitchFamily="34" charset="0"/>
+                <a:ea typeface="Calibri" pitchFamily="34" charset="-122"/>
+                <a:cs typeface="Calibri" pitchFamily="34" charset="-120"/>
+              </a:rPr>
+              <a:t>P1</a:t>
+            </a:r>
+            <a:endParaRPr lang="en-US" sz="800" dirty="0"/>
+          </a:p>
+        </p:txBody>
+      </p:sp>
+      <p:sp>
+        <p:nvSpPr>
+          <p:cNvPr id="16" name="Shape 13"/>
           <p:cNvSpPr/>
           <p:nvPr/>
         </p:nvSpPr>
@@ -7373,7 +7490,46 @@
       </p:sp>
       <p:sp>
         <p:nvSpPr>
-          <p:cNvPr id="14" name="Shape 11"/>
+          <p:cNvPr id="17" name="Text 14"/>
+          <p:cNvSpPr/>
+          <p:nvPr/>
+        </p:nvSpPr>
+        <p:spPr>
+          <a:xfrm>
+            <a:off x="2112264" y="3337560"/>
+            <a:ext cx="329184" cy="329184"/>
+          </a:xfrm>
+          <a:prstGeom prst="rect">
+            <a:avLst/>
+          </a:prstGeom>
+          <a:noFill/>
+          <a:ln/>
+        </p:spPr>
+        <p:txBody>
+          <a:bodyPr wrap="square" rtlCol="0" anchor="ctr"/>
+          <a:lstStyle/>
+          <a:p>
+            <a:pPr algn="ctr" indent="0" marL="0">
+              <a:buNone/>
+            </a:pPr>
+            <a:r>
+              <a:rPr lang="en-US" sz="800" b="1" dirty="0">
+                <a:solidFill>
+                  <a:srgbClr val="FFFFFF"/>
+                </a:solidFill>
+                <a:latin typeface="Calibri" pitchFamily="34" charset="0"/>
+                <a:ea typeface="Calibri" pitchFamily="34" charset="-122"/>
+                <a:cs typeface="Calibri" pitchFamily="34" charset="-120"/>
+              </a:rPr>
+              <a:t>P3</a:t>
+            </a:r>
+            <a:endParaRPr lang="en-US" sz="800" dirty="0"/>
+          </a:p>
+        </p:txBody>
+      </p:sp>
+      <p:sp>
+        <p:nvSpPr>
+          <p:cNvPr id="18" name="Shape 15"/>
           <p:cNvSpPr/>
           <p:nvPr/>
         </p:nvSpPr>
@@ -7395,7 +7551,46 @@
       </p:sp>
       <p:sp>
         <p:nvSpPr>
-          <p:cNvPr id="15" name="Shape 12"/>
+          <p:cNvPr id="19" name="Text 16"/>
+          <p:cNvSpPr/>
+          <p:nvPr/>
+        </p:nvSpPr>
+        <p:spPr>
+          <a:xfrm>
+            <a:off x="960120" y="3721608"/>
+            <a:ext cx="329184" cy="329184"/>
+          </a:xfrm>
+          <a:prstGeom prst="rect">
+            <a:avLst/>
+          </a:prstGeom>
+          <a:noFill/>
+          <a:ln/>
+        </p:spPr>
+        <p:txBody>
+          <a:bodyPr wrap="square" rtlCol="0" anchor="ctr"/>
+          <a:lstStyle/>
+          <a:p>
+            <a:pPr algn="ctr" indent="0" marL="0">
+              <a:buNone/>
+            </a:pPr>
+            <a:r>
+              <a:rPr lang="en-US" sz="800" b="1" dirty="0">
+                <a:solidFill>
+                  <a:srgbClr val="FFFFFF"/>
+                </a:solidFill>
+                <a:latin typeface="Calibri" pitchFamily="34" charset="0"/>
+                <a:ea typeface="Calibri" pitchFamily="34" charset="-122"/>
+                <a:cs typeface="Calibri" pitchFamily="34" charset="-120"/>
+              </a:rPr>
+              <a:t>P2</a:t>
+            </a:r>
+            <a:endParaRPr lang="en-US" sz="800" dirty="0"/>
+          </a:p>
+        </p:txBody>
+      </p:sp>
+      <p:sp>
+        <p:nvSpPr>
+          <p:cNvPr id="20" name="Shape 17"/>
           <p:cNvSpPr/>
           <p:nvPr/>
         </p:nvSpPr>
@@ -7417,7 +7612,46 @@
       </p:sp>
       <p:sp>
         <p:nvSpPr>
-          <p:cNvPr id="16" name="Shape 13"/>
+          <p:cNvPr id="21" name="Text 18"/>
+          <p:cNvSpPr/>
+          <p:nvPr/>
+        </p:nvSpPr>
+        <p:spPr>
+          <a:xfrm>
+            <a:off x="1344168" y="3721608"/>
+            <a:ext cx="329184" cy="329184"/>
+          </a:xfrm>
+          <a:prstGeom prst="rect">
+            <a:avLst/>
+          </a:prstGeom>
+          <a:noFill/>
+          <a:ln/>
+        </p:spPr>
+        <p:txBody>
+          <a:bodyPr wrap="square" rtlCol="0" anchor="ctr"/>
+          <a:lstStyle/>
+          <a:p>
+            <a:pPr algn="ctr" indent="0" marL="0">
+              <a:buNone/>
+            </a:pPr>
+            <a:r>
+              <a:rPr lang="en-US" sz="800" b="1" dirty="0">
+                <a:solidFill>
+                  <a:srgbClr val="FFFFFF"/>
+                </a:solidFill>
+                <a:latin typeface="Calibri" pitchFamily="34" charset="0"/>
+                <a:ea typeface="Calibri" pitchFamily="34" charset="-122"/>
+                <a:cs typeface="Calibri" pitchFamily="34" charset="-120"/>
+              </a:rPr>
+              <a:t>P4</a:t>
+            </a:r>
+            <a:endParaRPr lang="en-US" sz="800" dirty="0"/>
+          </a:p>
+        </p:txBody>
+      </p:sp>
+      <p:sp>
+        <p:nvSpPr>
+          <p:cNvPr id="22" name="Shape 19"/>
           <p:cNvSpPr/>
           <p:nvPr/>
         </p:nvSpPr>
@@ -7439,7 +7673,46 @@
       </p:sp>
       <p:sp>
         <p:nvSpPr>
-          <p:cNvPr id="17" name="Shape 14"/>
+          <p:cNvPr id="23" name="Text 20"/>
+          <p:cNvSpPr/>
+          <p:nvPr/>
+        </p:nvSpPr>
+        <p:spPr>
+          <a:xfrm>
+            <a:off x="1728216" y="3721608"/>
+            <a:ext cx="329184" cy="329184"/>
+          </a:xfrm>
+          <a:prstGeom prst="rect">
+            <a:avLst/>
+          </a:prstGeom>
+          <a:noFill/>
+          <a:ln/>
+        </p:spPr>
+        <p:txBody>
+          <a:bodyPr wrap="square" rtlCol="0" anchor="ctr"/>
+          <a:lstStyle/>
+          <a:p>
+            <a:pPr algn="ctr" indent="0" marL="0">
+              <a:buNone/>
+            </a:pPr>
+            <a:r>
+              <a:rPr lang="en-US" sz="800" b="1" dirty="0">
+                <a:solidFill>
+                  <a:srgbClr val="FFFFFF"/>
+                </a:solidFill>
+                <a:latin typeface="Calibri" pitchFamily="34" charset="0"/>
+                <a:ea typeface="Calibri" pitchFamily="34" charset="-122"/>
+                <a:cs typeface="Calibri" pitchFamily="34" charset="-120"/>
+              </a:rPr>
+              <a:t>P1</a:t>
+            </a:r>
+            <a:endParaRPr lang="en-US" sz="800" dirty="0"/>
+          </a:p>
+        </p:txBody>
+      </p:sp>
+      <p:sp>
+        <p:nvSpPr>
+          <p:cNvPr id="24" name="Shape 21"/>
           <p:cNvSpPr/>
           <p:nvPr/>
         </p:nvSpPr>
@@ -7461,37 +7734,76 @@
       </p:sp>
       <p:sp>
         <p:nvSpPr>
-          <p:cNvPr id="18" name="Text 15"/>
-          <p:cNvSpPr/>
-          <p:nvPr/>
-        </p:nvSpPr>
-        <p:spPr>
-          <a:xfrm>
-            <a:off x="3505124" y="3063240"/>
-            <a:ext cx="1828800" cy="228600"/>
-          </a:xfrm>
-          <a:prstGeom prst="rect">
-            <a:avLst/>
-          </a:prstGeom>
-          <a:noFill/>
-          <a:ln/>
-        </p:spPr>
-        <p:txBody>
-          <a:bodyPr wrap="square" rtlCol="0" anchor="ctr"/>
-          <a:lstStyle/>
-          <a:p>
-            <a:pPr indent="0" marL="0">
-              <a:buNone/>
-            </a:pPr>
-            <a:r>
-              <a:rPr lang="en-US" sz="900" b="1" spc="100" kern="0" dirty="0">
-                <a:solidFill>
-                  <a:srgbClr val="6B7394"/>
+          <p:cNvPr id="25" name="Text 22"/>
+          <p:cNvSpPr/>
+          <p:nvPr/>
+        </p:nvSpPr>
+        <p:spPr>
+          <a:xfrm>
+            <a:off x="2112264" y="3721608"/>
+            <a:ext cx="329184" cy="329184"/>
+          </a:xfrm>
+          <a:prstGeom prst="rect">
+            <a:avLst/>
+          </a:prstGeom>
+          <a:noFill/>
+          <a:ln/>
+        </p:spPr>
+        <p:txBody>
+          <a:bodyPr wrap="square" rtlCol="0" anchor="ctr"/>
+          <a:lstStyle/>
+          <a:p>
+            <a:pPr algn="ctr" indent="0" marL="0">
+              <a:buNone/>
+            </a:pPr>
+            <a:r>
+              <a:rPr lang="en-US" sz="800" b="1" dirty="0">
+                <a:solidFill>
+                  <a:srgbClr val="FFFFFF"/>
                 </a:solidFill>
                 <a:latin typeface="Calibri" pitchFamily="34" charset="0"/>
                 <a:ea typeface="Calibri" pitchFamily="34" charset="-122"/>
                 <a:cs typeface="Calibri" pitchFamily="34" charset="-120"/>
               </a:rPr>
+              <a:t>P3</a:t>
+            </a:r>
+            <a:endParaRPr lang="en-US" sz="800" dirty="0"/>
+          </a:p>
+        </p:txBody>
+      </p:sp>
+      <p:sp>
+        <p:nvSpPr>
+          <p:cNvPr id="26" name="Text 23"/>
+          <p:cNvSpPr/>
+          <p:nvPr/>
+        </p:nvSpPr>
+        <p:spPr>
+          <a:xfrm>
+            <a:off x="3505124" y="3063240"/>
+            <a:ext cx="1828800" cy="228600"/>
+          </a:xfrm>
+          <a:prstGeom prst="rect">
+            <a:avLst/>
+          </a:prstGeom>
+          <a:noFill/>
+          <a:ln/>
+        </p:spPr>
+        <p:txBody>
+          <a:bodyPr wrap="square" rtlCol="0" anchor="ctr"/>
+          <a:lstStyle/>
+          <a:p>
+            <a:pPr indent="0" marL="0">
+              <a:buNone/>
+            </a:pPr>
+            <a:r>
+              <a:rPr lang="en-US" sz="900" b="1" spc="100" kern="0" dirty="0">
+                <a:solidFill>
+                  <a:srgbClr val="6B7394"/>
+                </a:solidFill>
+                <a:latin typeface="Calibri" pitchFamily="34" charset="0"/>
+                <a:ea typeface="Calibri" pitchFamily="34" charset="-122"/>
+                <a:cs typeface="Calibri" pitchFamily="34" charset="-120"/>
+              </a:rPr>
               <a:t>Test</a:t>
             </a:r>
             <a:endParaRPr lang="en-US" sz="900" dirty="0"/>
@@ -7500,7 +7812,7 @@
       </p:sp>
       <p:sp>
         <p:nvSpPr>
-          <p:cNvPr id="19" name="Shape 16"/>
+          <p:cNvPr id="27" name="Shape 24"/>
           <p:cNvSpPr/>
           <p:nvPr/>
         </p:nvSpPr>
@@ -7522,7 +7834,46 @@
       </p:sp>
       <p:sp>
         <p:nvSpPr>
-          <p:cNvPr id="20" name="Shape 17"/>
+          <p:cNvPr id="28" name="Text 25"/>
+          <p:cNvSpPr/>
+          <p:nvPr/>
+        </p:nvSpPr>
+        <p:spPr>
+          <a:xfrm>
+            <a:off x="3505124" y="3337560"/>
+            <a:ext cx="329184" cy="329184"/>
+          </a:xfrm>
+          <a:prstGeom prst="rect">
+            <a:avLst/>
+          </a:prstGeom>
+          <a:noFill/>
+          <a:ln/>
+        </p:spPr>
+        <p:txBody>
+          <a:bodyPr wrap="square" rtlCol="0" anchor="ctr"/>
+          <a:lstStyle/>
+          <a:p>
+            <a:pPr algn="ctr" indent="0" marL="0">
+              <a:buNone/>
+            </a:pPr>
+            <a:r>
+              <a:rPr lang="en-US" sz="800" b="1" dirty="0">
+                <a:solidFill>
+                  <a:srgbClr val="FFFFFF"/>
+                </a:solidFill>
+                <a:latin typeface="Calibri" pitchFamily="34" charset="0"/>
+                <a:ea typeface="Calibri" pitchFamily="34" charset="-122"/>
+                <a:cs typeface="Calibri" pitchFamily="34" charset="-120"/>
+              </a:rPr>
+              <a:t>P3</a:t>
+            </a:r>
+            <a:endParaRPr lang="en-US" sz="800" dirty="0"/>
+          </a:p>
+        </p:txBody>
+      </p:sp>
+      <p:sp>
+        <p:nvSpPr>
+          <p:cNvPr id="29" name="Shape 26"/>
           <p:cNvSpPr/>
           <p:nvPr/>
         </p:nvSpPr>
@@ -7544,7 +7895,46 @@
       </p:sp>
       <p:sp>
         <p:nvSpPr>
-          <p:cNvPr id="21" name="Shape 18"/>
+          <p:cNvPr id="30" name="Text 27"/>
+          <p:cNvSpPr/>
+          <p:nvPr/>
+        </p:nvSpPr>
+        <p:spPr>
+          <a:xfrm>
+            <a:off x="3889172" y="3337560"/>
+            <a:ext cx="329184" cy="329184"/>
+          </a:xfrm>
+          <a:prstGeom prst="rect">
+            <a:avLst/>
+          </a:prstGeom>
+          <a:noFill/>
+          <a:ln/>
+        </p:spPr>
+        <p:txBody>
+          <a:bodyPr wrap="square" rtlCol="0" anchor="ctr"/>
+          <a:lstStyle/>
+          <a:p>
+            <a:pPr algn="ctr" indent="0" marL="0">
+              <a:buNone/>
+            </a:pPr>
+            <a:r>
+              <a:rPr lang="en-US" sz="800" b="1" dirty="0">
+                <a:solidFill>
+                  <a:srgbClr val="FFFFFF"/>
+                </a:solidFill>
+                <a:latin typeface="Calibri" pitchFamily="34" charset="0"/>
+                <a:ea typeface="Calibri" pitchFamily="34" charset="-122"/>
+                <a:cs typeface="Calibri" pitchFamily="34" charset="-120"/>
+              </a:rPr>
+              <a:t>P1</a:t>
+            </a:r>
+            <a:endParaRPr lang="en-US" sz="800" dirty="0"/>
+          </a:p>
+        </p:txBody>
+      </p:sp>
+      <p:sp>
+        <p:nvSpPr>
+          <p:cNvPr id="31" name="Shape 28"/>
           <p:cNvSpPr/>
           <p:nvPr/>
         </p:nvSpPr>
@@ -7566,7 +7956,46 @@
       </p:sp>
       <p:sp>
         <p:nvSpPr>
-          <p:cNvPr id="22" name="Shape 19"/>
+          <p:cNvPr id="32" name="Text 29"/>
+          <p:cNvSpPr/>
+          <p:nvPr/>
+        </p:nvSpPr>
+        <p:spPr>
+          <a:xfrm>
+            <a:off x="4273220" y="3337560"/>
+            <a:ext cx="329184" cy="329184"/>
+          </a:xfrm>
+          <a:prstGeom prst="rect">
+            <a:avLst/>
+          </a:prstGeom>
+          <a:noFill/>
+          <a:ln/>
+        </p:spPr>
+        <p:txBody>
+          <a:bodyPr wrap="square" rtlCol="0" anchor="ctr"/>
+          <a:lstStyle/>
+          <a:p>
+            <a:pPr algn="ctr" indent="0" marL="0">
+              <a:buNone/>
+            </a:pPr>
+            <a:r>
+              <a:rPr lang="en-US" sz="800" b="1" dirty="0">
+                <a:solidFill>
+                  <a:srgbClr val="FFFFFF"/>
+                </a:solidFill>
+                <a:latin typeface="Calibri" pitchFamily="34" charset="0"/>
+                <a:ea typeface="Calibri" pitchFamily="34" charset="-122"/>
+                <a:cs typeface="Calibri" pitchFamily="34" charset="-120"/>
+              </a:rPr>
+              <a:t>P2</a:t>
+            </a:r>
+            <a:endParaRPr lang="en-US" sz="800" dirty="0"/>
+          </a:p>
+        </p:txBody>
+      </p:sp>
+      <p:sp>
+        <p:nvSpPr>
+          <p:cNvPr id="33" name="Shape 30"/>
           <p:cNvSpPr/>
           <p:nvPr/>
         </p:nvSpPr>
@@ -7588,7 +8017,46 @@
       </p:sp>
       <p:sp>
         <p:nvSpPr>
-          <p:cNvPr id="23" name="Shape 20"/>
+          <p:cNvPr id="34" name="Text 31"/>
+          <p:cNvSpPr/>
+          <p:nvPr/>
+        </p:nvSpPr>
+        <p:spPr>
+          <a:xfrm>
+            <a:off x="4657268" y="3337560"/>
+            <a:ext cx="329184" cy="329184"/>
+          </a:xfrm>
+          <a:prstGeom prst="rect">
+            <a:avLst/>
+          </a:prstGeom>
+          <a:noFill/>
+          <a:ln/>
+        </p:spPr>
+        <p:txBody>
+          <a:bodyPr wrap="square" rtlCol="0" anchor="ctr"/>
+          <a:lstStyle/>
+          <a:p>
+            <a:pPr algn="ctr" indent="0" marL="0">
+              <a:buNone/>
+            </a:pPr>
+            <a:r>
+              <a:rPr lang="en-US" sz="800" b="1" dirty="0">
+                <a:solidFill>
+                  <a:srgbClr val="FFFFFF"/>
+                </a:solidFill>
+                <a:latin typeface="Calibri" pitchFamily="34" charset="0"/>
+                <a:ea typeface="Calibri" pitchFamily="34" charset="-122"/>
+                <a:cs typeface="Calibri" pitchFamily="34" charset="-120"/>
+              </a:rPr>
+              <a:t>P1</a:t>
+            </a:r>
+            <a:endParaRPr lang="en-US" sz="800" dirty="0"/>
+          </a:p>
+        </p:txBody>
+      </p:sp>
+      <p:sp>
+        <p:nvSpPr>
+          <p:cNvPr id="35" name="Shape 32"/>
           <p:cNvSpPr/>
           <p:nvPr/>
         </p:nvSpPr>
@@ -7610,7 +8078,46 @@
       </p:sp>
       <p:sp>
         <p:nvSpPr>
-          <p:cNvPr id="24" name="Shape 21"/>
+          <p:cNvPr id="36" name="Text 33"/>
+          <p:cNvSpPr/>
+          <p:nvPr/>
+        </p:nvSpPr>
+        <p:spPr>
+          <a:xfrm>
+            <a:off x="3505124" y="3721608"/>
+            <a:ext cx="329184" cy="329184"/>
+          </a:xfrm>
+          <a:prstGeom prst="rect">
+            <a:avLst/>
+          </a:prstGeom>
+          <a:noFill/>
+          <a:ln/>
+        </p:spPr>
+        <p:txBody>
+          <a:bodyPr wrap="square" rtlCol="0" anchor="ctr"/>
+          <a:lstStyle/>
+          <a:p>
+            <a:pPr algn="ctr" indent="0" marL="0">
+              <a:buNone/>
+            </a:pPr>
+            <a:r>
+              <a:rPr lang="en-US" sz="800" b="1" dirty="0">
+                <a:solidFill>
+                  <a:srgbClr val="FFFFFF"/>
+                </a:solidFill>
+                <a:latin typeface="Calibri" pitchFamily="34" charset="0"/>
+                <a:ea typeface="Calibri" pitchFamily="34" charset="-122"/>
+                <a:cs typeface="Calibri" pitchFamily="34" charset="-120"/>
+              </a:rPr>
+              <a:t>P1</a:t>
+            </a:r>
+            <a:endParaRPr lang="en-US" sz="800" dirty="0"/>
+          </a:p>
+        </p:txBody>
+      </p:sp>
+      <p:sp>
+        <p:nvSpPr>
+          <p:cNvPr id="37" name="Shape 34"/>
           <p:cNvSpPr/>
           <p:nvPr/>
         </p:nvSpPr>
@@ -7632,7 +8139,46 @@
       </p:sp>
       <p:sp>
         <p:nvSpPr>
-          <p:cNvPr id="25" name="Shape 22"/>
+          <p:cNvPr id="38" name="Text 35"/>
+          <p:cNvSpPr/>
+          <p:nvPr/>
+        </p:nvSpPr>
+        <p:spPr>
+          <a:xfrm>
+            <a:off x="3889172" y="3721608"/>
+            <a:ext cx="329184" cy="329184"/>
+          </a:xfrm>
+          <a:prstGeom prst="rect">
+            <a:avLst/>
+          </a:prstGeom>
+          <a:noFill/>
+          <a:ln/>
+        </p:spPr>
+        <p:txBody>
+          <a:bodyPr wrap="square" rtlCol="0" anchor="ctr"/>
+          <a:lstStyle/>
+          <a:p>
+            <a:pPr algn="ctr" indent="0" marL="0">
+              <a:buNone/>
+            </a:pPr>
+            <a:r>
+              <a:rPr lang="en-US" sz="800" b="1" dirty="0">
+                <a:solidFill>
+                  <a:srgbClr val="FFFFFF"/>
+                </a:solidFill>
+                <a:latin typeface="Calibri" pitchFamily="34" charset="0"/>
+                <a:ea typeface="Calibri" pitchFamily="34" charset="-122"/>
+                <a:cs typeface="Calibri" pitchFamily="34" charset="-120"/>
+              </a:rPr>
+              <a:t>P2</a:t>
+            </a:r>
+            <a:endParaRPr lang="en-US" sz="800" dirty="0"/>
+          </a:p>
+        </p:txBody>
+      </p:sp>
+      <p:sp>
+        <p:nvSpPr>
+          <p:cNvPr id="39" name="Shape 36"/>
           <p:cNvSpPr/>
           <p:nvPr/>
         </p:nvSpPr>
@@ -7654,7 +8200,46 @@
       </p:sp>
       <p:sp>
         <p:nvSpPr>
-          <p:cNvPr id="26" name="Shape 23"/>
+          <p:cNvPr id="40" name="Text 37"/>
+          <p:cNvSpPr/>
+          <p:nvPr/>
+        </p:nvSpPr>
+        <p:spPr>
+          <a:xfrm>
+            <a:off x="4273220" y="3721608"/>
+            <a:ext cx="329184" cy="329184"/>
+          </a:xfrm>
+          <a:prstGeom prst="rect">
+            <a:avLst/>
+          </a:prstGeom>
+          <a:noFill/>
+          <a:ln/>
+        </p:spPr>
+        <p:txBody>
+          <a:bodyPr wrap="square" rtlCol="0" anchor="ctr"/>
+          <a:lstStyle/>
+          <a:p>
+            <a:pPr algn="ctr" indent="0" marL="0">
+              <a:buNone/>
+            </a:pPr>
+            <a:r>
+              <a:rPr lang="en-US" sz="800" b="1" dirty="0">
+                <a:solidFill>
+                  <a:srgbClr val="FFFFFF"/>
+                </a:solidFill>
+                <a:latin typeface="Calibri" pitchFamily="34" charset="0"/>
+                <a:ea typeface="Calibri" pitchFamily="34" charset="-122"/>
+                <a:cs typeface="Calibri" pitchFamily="34" charset="-120"/>
+              </a:rPr>
+              <a:t>P3</a:t>
+            </a:r>
+            <a:endParaRPr lang="en-US" sz="800" dirty="0"/>
+          </a:p>
+        </p:txBody>
+      </p:sp>
+      <p:sp>
+        <p:nvSpPr>
+          <p:cNvPr id="41" name="Shape 38"/>
           <p:cNvSpPr/>
           <p:nvPr/>
         </p:nvSpPr>
@@ -7676,37 +8261,76 @@
       </p:sp>
       <p:sp>
         <p:nvSpPr>
-          <p:cNvPr id="27" name="Text 24"/>
-          <p:cNvSpPr/>
-          <p:nvPr/>
-        </p:nvSpPr>
-        <p:spPr>
-          <a:xfrm>
-            <a:off x="960120" y="5029200"/>
-            <a:ext cx="4724248" cy="365760"/>
-          </a:xfrm>
-          <a:prstGeom prst="rect">
-            <a:avLst/>
-          </a:prstGeom>
-          <a:noFill/>
-          <a:ln/>
-        </p:spPr>
-        <p:txBody>
-          <a:bodyPr wrap="square" rtlCol="0" anchor="ctr"/>
-          <a:lstStyle/>
-          <a:p>
-            <a:pPr indent="0" marL="0">
-              <a:buNone/>
-            </a:pPr>
-            <a:r>
-              <a:rPr lang="en-US" sz="1100" dirty="0">
-                <a:solidFill>
-                  <a:srgbClr val="3D4873"/>
+          <p:cNvPr id="42" name="Text 39"/>
+          <p:cNvSpPr/>
+          <p:nvPr/>
+        </p:nvSpPr>
+        <p:spPr>
+          <a:xfrm>
+            <a:off x="4657268" y="3721608"/>
+            <a:ext cx="329184" cy="329184"/>
+          </a:xfrm>
+          <a:prstGeom prst="rect">
+            <a:avLst/>
+          </a:prstGeom>
+          <a:noFill/>
+          <a:ln/>
+        </p:spPr>
+        <p:txBody>
+          <a:bodyPr wrap="square" rtlCol="0" anchor="ctr"/>
+          <a:lstStyle/>
+          <a:p>
+            <a:pPr algn="ctr" indent="0" marL="0">
+              <a:buNone/>
+            </a:pPr>
+            <a:r>
+              <a:rPr lang="en-US" sz="800" b="1" dirty="0">
+                <a:solidFill>
+                  <a:srgbClr val="FFFFFF"/>
                 </a:solidFill>
                 <a:latin typeface="Calibri" pitchFamily="34" charset="0"/>
                 <a:ea typeface="Calibri" pitchFamily="34" charset="-122"/>
                 <a:cs typeface="Calibri" pitchFamily="34" charset="-120"/>
               </a:rPr>
+              <a:t>P1</a:t>
+            </a:r>
+            <a:endParaRPr lang="en-US" sz="800" dirty="0"/>
+          </a:p>
+        </p:txBody>
+      </p:sp>
+      <p:sp>
+        <p:nvSpPr>
+          <p:cNvPr id="43" name="Text 40"/>
+          <p:cNvSpPr/>
+          <p:nvPr/>
+        </p:nvSpPr>
+        <p:spPr>
+          <a:xfrm>
+            <a:off x="960120" y="5029200"/>
+            <a:ext cx="4724248" cy="365760"/>
+          </a:xfrm>
+          <a:prstGeom prst="rect">
+            <a:avLst/>
+          </a:prstGeom>
+          <a:noFill/>
+          <a:ln/>
+        </p:spPr>
+        <p:txBody>
+          <a:bodyPr wrap="square" rtlCol="0" anchor="ctr"/>
+          <a:lstStyle/>
+          <a:p>
+            <a:pPr indent="0" marL="0">
+              <a:buNone/>
+            </a:pPr>
+            <a:r>
+              <a:rPr lang="en-US" sz="1100" dirty="0">
+                <a:solidFill>
+                  <a:srgbClr val="3D4873"/>
+                </a:solidFill>
+                <a:latin typeface="Calibri" pitchFamily="34" charset="0"/>
+                <a:ea typeface="Calibri" pitchFamily="34" charset="-122"/>
+                <a:cs typeface="Calibri" pitchFamily="34" charset="-120"/>
+              </a:rPr>
               <a:t>P1, P2, P3 leak into the test set.</a:t>
             </a:r>
             <a:endParaRPr lang="en-US" sz="1100" dirty="0"/>
@@ -7715,7 +8339,7 @@
       </p:sp>
       <p:sp>
         <p:nvSpPr>
-          <p:cNvPr id="28" name="Shape 25"/>
+          <p:cNvPr id="44" name="Shape 41"/>
           <p:cNvSpPr/>
           <p:nvPr/>
         </p:nvSpPr>
@@ -7742,7 +8366,7 @@
       </p:sp>
       <p:sp>
         <p:nvSpPr>
-          <p:cNvPr id="29" name="Text 26"/>
+          <p:cNvPr id="45" name="Text 42"/>
           <p:cNvSpPr/>
           <p:nvPr/>
         </p:nvSpPr>
@@ -7781,7 +8405,7 @@
       </p:sp>
       <p:sp>
         <p:nvSpPr>
-          <p:cNvPr id="30" name="Text 27"/>
+          <p:cNvPr id="46" name="Text 43"/>
           <p:cNvSpPr/>
           <p:nvPr/>
         </p:nvSpPr>
@@ -7820,7 +8444,7 @@
       </p:sp>
       <p:sp>
         <p:nvSpPr>
-          <p:cNvPr id="31" name="Shape 28"/>
+          <p:cNvPr id="47" name="Shape 44"/>
           <p:cNvSpPr/>
           <p:nvPr/>
         </p:nvSpPr>
@@ -7842,7 +8466,46 @@
       </p:sp>
       <p:sp>
         <p:nvSpPr>
-          <p:cNvPr id="32" name="Shape 29"/>
+          <p:cNvPr id="48" name="Text 45"/>
+          <p:cNvSpPr/>
+          <p:nvPr/>
+        </p:nvSpPr>
+        <p:spPr>
+          <a:xfrm>
+            <a:off x="6644488" y="3337560"/>
+            <a:ext cx="329184" cy="329184"/>
+          </a:xfrm>
+          <a:prstGeom prst="rect">
+            <a:avLst/>
+          </a:prstGeom>
+          <a:noFill/>
+          <a:ln/>
+        </p:spPr>
+        <p:txBody>
+          <a:bodyPr wrap="square" rtlCol="0" anchor="ctr"/>
+          <a:lstStyle/>
+          <a:p>
+            <a:pPr algn="ctr" indent="0" marL="0">
+              <a:buNone/>
+            </a:pPr>
+            <a:r>
+              <a:rPr lang="en-US" sz="800" b="1" dirty="0">
+                <a:solidFill>
+                  <a:srgbClr val="FFFFFF"/>
+                </a:solidFill>
+                <a:latin typeface="Calibri" pitchFamily="34" charset="0"/>
+                <a:ea typeface="Calibri" pitchFamily="34" charset="-122"/>
+                <a:cs typeface="Calibri" pitchFamily="34" charset="-120"/>
+              </a:rPr>
+              <a:t>P1</a:t>
+            </a:r>
+            <a:endParaRPr lang="en-US" sz="800" dirty="0"/>
+          </a:p>
+        </p:txBody>
+      </p:sp>
+      <p:sp>
+        <p:nvSpPr>
+          <p:cNvPr id="49" name="Shape 46"/>
           <p:cNvSpPr/>
           <p:nvPr/>
         </p:nvSpPr>
@@ -7864,7 +8527,46 @@
       </p:sp>
       <p:sp>
         <p:nvSpPr>
-          <p:cNvPr id="33" name="Shape 30"/>
+          <p:cNvPr id="50" name="Text 47"/>
+          <p:cNvSpPr/>
+          <p:nvPr/>
+        </p:nvSpPr>
+        <p:spPr>
+          <a:xfrm>
+            <a:off x="7028536" y="3337560"/>
+            <a:ext cx="329184" cy="329184"/>
+          </a:xfrm>
+          <a:prstGeom prst="rect">
+            <a:avLst/>
+          </a:prstGeom>
+          <a:noFill/>
+          <a:ln/>
+        </p:spPr>
+        <p:txBody>
+          <a:bodyPr wrap="square" rtlCol="0" anchor="ctr"/>
+          <a:lstStyle/>
+          <a:p>
+            <a:pPr algn="ctr" indent="0" marL="0">
+              <a:buNone/>
+            </a:pPr>
+            <a:r>
+              <a:rPr lang="en-US" sz="800" b="1" dirty="0">
+                <a:solidFill>
+                  <a:srgbClr val="FFFFFF"/>
+                </a:solidFill>
+                <a:latin typeface="Calibri" pitchFamily="34" charset="0"/>
+                <a:ea typeface="Calibri" pitchFamily="34" charset="-122"/>
+                <a:cs typeface="Calibri" pitchFamily="34" charset="-120"/>
+              </a:rPr>
+              <a:t>P1</a:t>
+            </a:r>
+            <a:endParaRPr lang="en-US" sz="800" dirty="0"/>
+          </a:p>
+        </p:txBody>
+      </p:sp>
+      <p:sp>
+        <p:nvSpPr>
+          <p:cNvPr id="51" name="Shape 48"/>
           <p:cNvSpPr/>
           <p:nvPr/>
         </p:nvSpPr>
@@ -7886,7 +8588,46 @@
       </p:sp>
       <p:sp>
         <p:nvSpPr>
-          <p:cNvPr id="34" name="Shape 31"/>
+          <p:cNvPr id="52" name="Text 49"/>
+          <p:cNvSpPr/>
+          <p:nvPr/>
+        </p:nvSpPr>
+        <p:spPr>
+          <a:xfrm>
+            <a:off x="7412584" y="3337560"/>
+            <a:ext cx="329184" cy="329184"/>
+          </a:xfrm>
+          <a:prstGeom prst="rect">
+            <a:avLst/>
+          </a:prstGeom>
+          <a:noFill/>
+          <a:ln/>
+        </p:spPr>
+        <p:txBody>
+          <a:bodyPr wrap="square" rtlCol="0" anchor="ctr"/>
+          <a:lstStyle/>
+          <a:p>
+            <a:pPr algn="ctr" indent="0" marL="0">
+              <a:buNone/>
+            </a:pPr>
+            <a:r>
+              <a:rPr lang="en-US" sz="800" b="1" dirty="0">
+                <a:solidFill>
+                  <a:srgbClr val="FFFFFF"/>
+                </a:solidFill>
+                <a:latin typeface="Calibri" pitchFamily="34" charset="0"/>
+                <a:ea typeface="Calibri" pitchFamily="34" charset="-122"/>
+                <a:cs typeface="Calibri" pitchFamily="34" charset="-120"/>
+              </a:rPr>
+              <a:t>P1</a:t>
+            </a:r>
+            <a:endParaRPr lang="en-US" sz="800" dirty="0"/>
+          </a:p>
+        </p:txBody>
+      </p:sp>
+      <p:sp>
+        <p:nvSpPr>
+          <p:cNvPr id="53" name="Shape 50"/>
           <p:cNvSpPr/>
           <p:nvPr/>
         </p:nvSpPr>
@@ -7908,7 +8649,46 @@
       </p:sp>
       <p:sp>
         <p:nvSpPr>
-          <p:cNvPr id="35" name="Shape 32"/>
+          <p:cNvPr id="54" name="Text 51"/>
+          <p:cNvSpPr/>
+          <p:nvPr/>
+        </p:nvSpPr>
+        <p:spPr>
+          <a:xfrm>
+            <a:off x="7796632" y="3337560"/>
+            <a:ext cx="329184" cy="329184"/>
+          </a:xfrm>
+          <a:prstGeom prst="rect">
+            <a:avLst/>
+          </a:prstGeom>
+          <a:noFill/>
+          <a:ln/>
+        </p:spPr>
+        <p:txBody>
+          <a:bodyPr wrap="square" rtlCol="0" anchor="ctr"/>
+          <a:lstStyle/>
+          <a:p>
+            <a:pPr algn="ctr" indent="0" marL="0">
+              <a:buNone/>
+            </a:pPr>
+            <a:r>
+              <a:rPr lang="en-US" sz="800" b="1" dirty="0">
+                <a:solidFill>
+                  <a:srgbClr val="FFFFFF"/>
+                </a:solidFill>
+                <a:latin typeface="Calibri" pitchFamily="34" charset="0"/>
+                <a:ea typeface="Calibri" pitchFamily="34" charset="-122"/>
+                <a:cs typeface="Calibri" pitchFamily="34" charset="-120"/>
+              </a:rPr>
+              <a:t>P1</a:t>
+            </a:r>
+            <a:endParaRPr lang="en-US" sz="800" dirty="0"/>
+          </a:p>
+        </p:txBody>
+      </p:sp>
+      <p:sp>
+        <p:nvSpPr>
+          <p:cNvPr id="55" name="Shape 52"/>
           <p:cNvSpPr/>
           <p:nvPr/>
         </p:nvSpPr>
@@ -7930,7 +8710,46 @@
       </p:sp>
       <p:sp>
         <p:nvSpPr>
-          <p:cNvPr id="36" name="Shape 33"/>
+          <p:cNvPr id="56" name="Text 53"/>
+          <p:cNvSpPr/>
+          <p:nvPr/>
+        </p:nvSpPr>
+        <p:spPr>
+          <a:xfrm>
+            <a:off x="6644488" y="3721608"/>
+            <a:ext cx="329184" cy="329184"/>
+          </a:xfrm>
+          <a:prstGeom prst="rect">
+            <a:avLst/>
+          </a:prstGeom>
+          <a:noFill/>
+          <a:ln/>
+        </p:spPr>
+        <p:txBody>
+          <a:bodyPr wrap="square" rtlCol="0" anchor="ctr"/>
+          <a:lstStyle/>
+          <a:p>
+            <a:pPr algn="ctr" indent="0" marL="0">
+              <a:buNone/>
+            </a:pPr>
+            <a:r>
+              <a:rPr lang="en-US" sz="800" b="1" dirty="0">
+                <a:solidFill>
+                  <a:srgbClr val="FFFFFF"/>
+                </a:solidFill>
+                <a:latin typeface="Calibri" pitchFamily="34" charset="0"/>
+                <a:ea typeface="Calibri" pitchFamily="34" charset="-122"/>
+                <a:cs typeface="Calibri" pitchFamily="34" charset="-120"/>
+              </a:rPr>
+              <a:t>P2</a:t>
+            </a:r>
+            <a:endParaRPr lang="en-US" sz="800" dirty="0"/>
+          </a:p>
+        </p:txBody>
+      </p:sp>
+      <p:sp>
+        <p:nvSpPr>
+          <p:cNvPr id="57" name="Shape 54"/>
           <p:cNvSpPr/>
           <p:nvPr/>
         </p:nvSpPr>
@@ -7952,7 +8771,46 @@
       </p:sp>
       <p:sp>
         <p:nvSpPr>
-          <p:cNvPr id="37" name="Shape 34"/>
+          <p:cNvPr id="58" name="Text 55"/>
+          <p:cNvSpPr/>
+          <p:nvPr/>
+        </p:nvSpPr>
+        <p:spPr>
+          <a:xfrm>
+            <a:off x="7028536" y="3721608"/>
+            <a:ext cx="329184" cy="329184"/>
+          </a:xfrm>
+          <a:prstGeom prst="rect">
+            <a:avLst/>
+          </a:prstGeom>
+          <a:noFill/>
+          <a:ln/>
+        </p:spPr>
+        <p:txBody>
+          <a:bodyPr wrap="square" rtlCol="0" anchor="ctr"/>
+          <a:lstStyle/>
+          <a:p>
+            <a:pPr algn="ctr" indent="0" marL="0">
+              <a:buNone/>
+            </a:pPr>
+            <a:r>
+              <a:rPr lang="en-US" sz="800" b="1" dirty="0">
+                <a:solidFill>
+                  <a:srgbClr val="FFFFFF"/>
+                </a:solidFill>
+                <a:latin typeface="Calibri" pitchFamily="34" charset="0"/>
+                <a:ea typeface="Calibri" pitchFamily="34" charset="-122"/>
+                <a:cs typeface="Calibri" pitchFamily="34" charset="-120"/>
+              </a:rPr>
+              <a:t>P2</a:t>
+            </a:r>
+            <a:endParaRPr lang="en-US" sz="800" dirty="0"/>
+          </a:p>
+        </p:txBody>
+      </p:sp>
+      <p:sp>
+        <p:nvSpPr>
+          <p:cNvPr id="59" name="Shape 56"/>
           <p:cNvSpPr/>
           <p:nvPr/>
         </p:nvSpPr>
@@ -7974,7 +8832,46 @@
       </p:sp>
       <p:sp>
         <p:nvSpPr>
-          <p:cNvPr id="38" name="Shape 35"/>
+          <p:cNvPr id="60" name="Text 57"/>
+          <p:cNvSpPr/>
+          <p:nvPr/>
+        </p:nvSpPr>
+        <p:spPr>
+          <a:xfrm>
+            <a:off x="7412584" y="3721608"/>
+            <a:ext cx="329184" cy="329184"/>
+          </a:xfrm>
+          <a:prstGeom prst="rect">
+            <a:avLst/>
+          </a:prstGeom>
+          <a:noFill/>
+          <a:ln/>
+        </p:spPr>
+        <p:txBody>
+          <a:bodyPr wrap="square" rtlCol="0" anchor="ctr"/>
+          <a:lstStyle/>
+          <a:p>
+            <a:pPr algn="ctr" indent="0" marL="0">
+              <a:buNone/>
+            </a:pPr>
+            <a:r>
+              <a:rPr lang="en-US" sz="800" b="1" dirty="0">
+                <a:solidFill>
+                  <a:srgbClr val="FFFFFF"/>
+                </a:solidFill>
+                <a:latin typeface="Calibri" pitchFamily="34" charset="0"/>
+                <a:ea typeface="Calibri" pitchFamily="34" charset="-122"/>
+                <a:cs typeface="Calibri" pitchFamily="34" charset="-120"/>
+              </a:rPr>
+              <a:t>P2</a:t>
+            </a:r>
+            <a:endParaRPr lang="en-US" sz="800" dirty="0"/>
+          </a:p>
+        </p:txBody>
+      </p:sp>
+      <p:sp>
+        <p:nvSpPr>
+          <p:cNvPr id="61" name="Shape 58"/>
           <p:cNvSpPr/>
           <p:nvPr/>
         </p:nvSpPr>
@@ -7996,37 +8893,76 @@
       </p:sp>
       <p:sp>
         <p:nvSpPr>
-          <p:cNvPr id="39" name="Text 36"/>
-          <p:cNvSpPr/>
-          <p:nvPr/>
-        </p:nvSpPr>
-        <p:spPr>
-          <a:xfrm>
-            <a:off x="9189491" y="3063240"/>
-            <a:ext cx="1828800" cy="228600"/>
-          </a:xfrm>
-          <a:prstGeom prst="rect">
-            <a:avLst/>
-          </a:prstGeom>
-          <a:noFill/>
-          <a:ln/>
-        </p:spPr>
-        <p:txBody>
-          <a:bodyPr wrap="square" rtlCol="0" anchor="ctr"/>
-          <a:lstStyle/>
-          <a:p>
-            <a:pPr indent="0" marL="0">
-              <a:buNone/>
-            </a:pPr>
-            <a:r>
-              <a:rPr lang="en-US" sz="900" b="1" spc="100" kern="0" dirty="0">
-                <a:solidFill>
-                  <a:srgbClr val="6B7394"/>
+          <p:cNvPr id="62" name="Text 59"/>
+          <p:cNvSpPr/>
+          <p:nvPr/>
+        </p:nvSpPr>
+        <p:spPr>
+          <a:xfrm>
+            <a:off x="7796632" y="3721608"/>
+            <a:ext cx="329184" cy="329184"/>
+          </a:xfrm>
+          <a:prstGeom prst="rect">
+            <a:avLst/>
+          </a:prstGeom>
+          <a:noFill/>
+          <a:ln/>
+        </p:spPr>
+        <p:txBody>
+          <a:bodyPr wrap="square" rtlCol="0" anchor="ctr"/>
+          <a:lstStyle/>
+          <a:p>
+            <a:pPr algn="ctr" indent="0" marL="0">
+              <a:buNone/>
+            </a:pPr>
+            <a:r>
+              <a:rPr lang="en-US" sz="800" b="1" dirty="0">
+                <a:solidFill>
+                  <a:srgbClr val="FFFFFF"/>
                 </a:solidFill>
                 <a:latin typeface="Calibri" pitchFamily="34" charset="0"/>
                 <a:ea typeface="Calibri" pitchFamily="34" charset="-122"/>
                 <a:cs typeface="Calibri" pitchFamily="34" charset="-120"/>
               </a:rPr>
+              <a:t>P2</a:t>
+            </a:r>
+            <a:endParaRPr lang="en-US" sz="800" dirty="0"/>
+          </a:p>
+        </p:txBody>
+      </p:sp>
+      <p:sp>
+        <p:nvSpPr>
+          <p:cNvPr id="63" name="Text 60"/>
+          <p:cNvSpPr/>
+          <p:nvPr/>
+        </p:nvSpPr>
+        <p:spPr>
+          <a:xfrm>
+            <a:off x="9189491" y="3063240"/>
+            <a:ext cx="1828800" cy="228600"/>
+          </a:xfrm>
+          <a:prstGeom prst="rect">
+            <a:avLst/>
+          </a:prstGeom>
+          <a:noFill/>
+          <a:ln/>
+        </p:spPr>
+        <p:txBody>
+          <a:bodyPr wrap="square" rtlCol="0" anchor="ctr"/>
+          <a:lstStyle/>
+          <a:p>
+            <a:pPr indent="0" marL="0">
+              <a:buNone/>
+            </a:pPr>
+            <a:r>
+              <a:rPr lang="en-US" sz="900" b="1" spc="100" kern="0" dirty="0">
+                <a:solidFill>
+                  <a:srgbClr val="6B7394"/>
+                </a:solidFill>
+                <a:latin typeface="Calibri" pitchFamily="34" charset="0"/>
+                <a:ea typeface="Calibri" pitchFamily="34" charset="-122"/>
+                <a:cs typeface="Calibri" pitchFamily="34" charset="-120"/>
+              </a:rPr>
               <a:t>Test</a:t>
             </a:r>
             <a:endParaRPr lang="en-US" sz="900" dirty="0"/>
@@ -8035,7 +8971,7 @@
       </p:sp>
       <p:sp>
         <p:nvSpPr>
-          <p:cNvPr id="40" name="Shape 37"/>
+          <p:cNvPr id="64" name="Shape 61"/>
           <p:cNvSpPr/>
           <p:nvPr/>
         </p:nvSpPr>
@@ -8057,7 +8993,46 @@
       </p:sp>
       <p:sp>
         <p:nvSpPr>
-          <p:cNvPr id="41" name="Shape 38"/>
+          <p:cNvPr id="65" name="Text 62"/>
+          <p:cNvSpPr/>
+          <p:nvPr/>
+        </p:nvSpPr>
+        <p:spPr>
+          <a:xfrm>
+            <a:off x="9189491" y="3337560"/>
+            <a:ext cx="329184" cy="329184"/>
+          </a:xfrm>
+          <a:prstGeom prst="rect">
+            <a:avLst/>
+          </a:prstGeom>
+          <a:noFill/>
+          <a:ln/>
+        </p:spPr>
+        <p:txBody>
+          <a:bodyPr wrap="square" rtlCol="0" anchor="ctr"/>
+          <a:lstStyle/>
+          <a:p>
+            <a:pPr algn="ctr" indent="0" marL="0">
+              <a:buNone/>
+            </a:pPr>
+            <a:r>
+              <a:rPr lang="en-US" sz="800" b="1" dirty="0">
+                <a:solidFill>
+                  <a:srgbClr val="FFFFFF"/>
+                </a:solidFill>
+                <a:latin typeface="Calibri" pitchFamily="34" charset="0"/>
+                <a:ea typeface="Calibri" pitchFamily="34" charset="-122"/>
+                <a:cs typeface="Calibri" pitchFamily="34" charset="-120"/>
+              </a:rPr>
+              <a:t>P3</a:t>
+            </a:r>
+            <a:endParaRPr lang="en-US" sz="800" dirty="0"/>
+          </a:p>
+        </p:txBody>
+      </p:sp>
+      <p:sp>
+        <p:nvSpPr>
+          <p:cNvPr id="66" name="Shape 63"/>
           <p:cNvSpPr/>
           <p:nvPr/>
         </p:nvSpPr>
@@ -8079,7 +9054,46 @@
       </p:sp>
       <p:sp>
         <p:nvSpPr>
-          <p:cNvPr id="42" name="Shape 39"/>
+          <p:cNvPr id="67" name="Text 64"/>
+          <p:cNvSpPr/>
+          <p:nvPr/>
+        </p:nvSpPr>
+        <p:spPr>
+          <a:xfrm>
+            <a:off x="9573539" y="3337560"/>
+            <a:ext cx="329184" cy="329184"/>
+          </a:xfrm>
+          <a:prstGeom prst="rect">
+            <a:avLst/>
+          </a:prstGeom>
+          <a:noFill/>
+          <a:ln/>
+        </p:spPr>
+        <p:txBody>
+          <a:bodyPr wrap="square" rtlCol="0" anchor="ctr"/>
+          <a:lstStyle/>
+          <a:p>
+            <a:pPr algn="ctr" indent="0" marL="0">
+              <a:buNone/>
+            </a:pPr>
+            <a:r>
+              <a:rPr lang="en-US" sz="800" b="1" dirty="0">
+                <a:solidFill>
+                  <a:srgbClr val="FFFFFF"/>
+                </a:solidFill>
+                <a:latin typeface="Calibri" pitchFamily="34" charset="0"/>
+                <a:ea typeface="Calibri" pitchFamily="34" charset="-122"/>
+                <a:cs typeface="Calibri" pitchFamily="34" charset="-120"/>
+              </a:rPr>
+              <a:t>P3</a:t>
+            </a:r>
+            <a:endParaRPr lang="en-US" sz="800" dirty="0"/>
+          </a:p>
+        </p:txBody>
+      </p:sp>
+      <p:sp>
+        <p:nvSpPr>
+          <p:cNvPr id="68" name="Shape 65"/>
           <p:cNvSpPr/>
           <p:nvPr/>
         </p:nvSpPr>
@@ -8101,7 +9115,46 @@
       </p:sp>
       <p:sp>
         <p:nvSpPr>
-          <p:cNvPr id="43" name="Shape 40"/>
+          <p:cNvPr id="69" name="Text 66"/>
+          <p:cNvSpPr/>
+          <p:nvPr/>
+        </p:nvSpPr>
+        <p:spPr>
+          <a:xfrm>
+            <a:off x="9957587" y="3337560"/>
+            <a:ext cx="329184" cy="329184"/>
+          </a:xfrm>
+          <a:prstGeom prst="rect">
+            <a:avLst/>
+          </a:prstGeom>
+          <a:noFill/>
+          <a:ln/>
+        </p:spPr>
+        <p:txBody>
+          <a:bodyPr wrap="square" rtlCol="0" anchor="ctr"/>
+          <a:lstStyle/>
+          <a:p>
+            <a:pPr algn="ctr" indent="0" marL="0">
+              <a:buNone/>
+            </a:pPr>
+            <a:r>
+              <a:rPr lang="en-US" sz="800" b="1" dirty="0">
+                <a:solidFill>
+                  <a:srgbClr val="FFFFFF"/>
+                </a:solidFill>
+                <a:latin typeface="Calibri" pitchFamily="34" charset="0"/>
+                <a:ea typeface="Calibri" pitchFamily="34" charset="-122"/>
+                <a:cs typeface="Calibri" pitchFamily="34" charset="-120"/>
+              </a:rPr>
+              <a:t>P3</a:t>
+            </a:r>
+            <a:endParaRPr lang="en-US" sz="800" dirty="0"/>
+          </a:p>
+        </p:txBody>
+      </p:sp>
+      <p:sp>
+        <p:nvSpPr>
+          <p:cNvPr id="70" name="Shape 67"/>
           <p:cNvSpPr/>
           <p:nvPr/>
         </p:nvSpPr>
@@ -8123,7 +9176,46 @@
       </p:sp>
       <p:sp>
         <p:nvSpPr>
-          <p:cNvPr id="44" name="Shape 41"/>
+          <p:cNvPr id="71" name="Text 68"/>
+          <p:cNvSpPr/>
+          <p:nvPr/>
+        </p:nvSpPr>
+        <p:spPr>
+          <a:xfrm>
+            <a:off x="10341635" y="3337560"/>
+            <a:ext cx="329184" cy="329184"/>
+          </a:xfrm>
+          <a:prstGeom prst="rect">
+            <a:avLst/>
+          </a:prstGeom>
+          <a:noFill/>
+          <a:ln/>
+        </p:spPr>
+        <p:txBody>
+          <a:bodyPr wrap="square" rtlCol="0" anchor="ctr"/>
+          <a:lstStyle/>
+          <a:p>
+            <a:pPr algn="ctr" indent="0" marL="0">
+              <a:buNone/>
+            </a:pPr>
+            <a:r>
+              <a:rPr lang="en-US" sz="800" b="1" dirty="0">
+                <a:solidFill>
+                  <a:srgbClr val="FFFFFF"/>
+                </a:solidFill>
+                <a:latin typeface="Calibri" pitchFamily="34" charset="0"/>
+                <a:ea typeface="Calibri" pitchFamily="34" charset="-122"/>
+                <a:cs typeface="Calibri" pitchFamily="34" charset="-120"/>
+              </a:rPr>
+              <a:t>P3</a:t>
+            </a:r>
+            <a:endParaRPr lang="en-US" sz="800" dirty="0"/>
+          </a:p>
+        </p:txBody>
+      </p:sp>
+      <p:sp>
+        <p:nvSpPr>
+          <p:cNvPr id="72" name="Shape 69"/>
           <p:cNvSpPr/>
           <p:nvPr/>
         </p:nvSpPr>
@@ -8145,7 +9237,46 @@
       </p:sp>
       <p:sp>
         <p:nvSpPr>
-          <p:cNvPr id="45" name="Shape 42"/>
+          <p:cNvPr id="73" name="Text 70"/>
+          <p:cNvSpPr/>
+          <p:nvPr/>
+        </p:nvSpPr>
+        <p:spPr>
+          <a:xfrm>
+            <a:off x="9189491" y="3721608"/>
+            <a:ext cx="329184" cy="329184"/>
+          </a:xfrm>
+          <a:prstGeom prst="rect">
+            <a:avLst/>
+          </a:prstGeom>
+          <a:noFill/>
+          <a:ln/>
+        </p:spPr>
+        <p:txBody>
+          <a:bodyPr wrap="square" rtlCol="0" anchor="ctr"/>
+          <a:lstStyle/>
+          <a:p>
+            <a:pPr algn="ctr" indent="0" marL="0">
+              <a:buNone/>
+            </a:pPr>
+            <a:r>
+              <a:rPr lang="en-US" sz="800" b="1" dirty="0">
+                <a:solidFill>
+                  <a:srgbClr val="FFFFFF"/>
+                </a:solidFill>
+                <a:latin typeface="Calibri" pitchFamily="34" charset="0"/>
+                <a:ea typeface="Calibri" pitchFamily="34" charset="-122"/>
+                <a:cs typeface="Calibri" pitchFamily="34" charset="-120"/>
+              </a:rPr>
+              <a:t>P4</a:t>
+            </a:r>
+            <a:endParaRPr lang="en-US" sz="800" dirty="0"/>
+          </a:p>
+        </p:txBody>
+      </p:sp>
+      <p:sp>
+        <p:nvSpPr>
+          <p:cNvPr id="74" name="Shape 71"/>
           <p:cNvSpPr/>
           <p:nvPr/>
         </p:nvSpPr>
@@ -8167,7 +9298,46 @@
       </p:sp>
       <p:sp>
         <p:nvSpPr>
-          <p:cNvPr id="46" name="Shape 43"/>
+          <p:cNvPr id="75" name="Text 72"/>
+          <p:cNvSpPr/>
+          <p:nvPr/>
+        </p:nvSpPr>
+        <p:spPr>
+          <a:xfrm>
+            <a:off x="9573539" y="3721608"/>
+            <a:ext cx="329184" cy="329184"/>
+          </a:xfrm>
+          <a:prstGeom prst="rect">
+            <a:avLst/>
+          </a:prstGeom>
+          <a:noFill/>
+          <a:ln/>
+        </p:spPr>
+        <p:txBody>
+          <a:bodyPr wrap="square" rtlCol="0" anchor="ctr"/>
+          <a:lstStyle/>
+          <a:p>
+            <a:pPr algn="ctr" indent="0" marL="0">
+              <a:buNone/>
+            </a:pPr>
+            <a:r>
+              <a:rPr lang="en-US" sz="800" b="1" dirty="0">
+                <a:solidFill>
+                  <a:srgbClr val="FFFFFF"/>
+                </a:solidFill>
+                <a:latin typeface="Calibri" pitchFamily="34" charset="0"/>
+                <a:ea typeface="Calibri" pitchFamily="34" charset="-122"/>
+                <a:cs typeface="Calibri" pitchFamily="34" charset="-120"/>
+              </a:rPr>
+              <a:t>P4</a:t>
+            </a:r>
+            <a:endParaRPr lang="en-US" sz="800" dirty="0"/>
+          </a:p>
+        </p:txBody>
+      </p:sp>
+      <p:sp>
+        <p:nvSpPr>
+          <p:cNvPr id="76" name="Shape 73"/>
           <p:cNvSpPr/>
           <p:nvPr/>
         </p:nvSpPr>
@@ -8189,7 +9359,46 @@
       </p:sp>
       <p:sp>
         <p:nvSpPr>
-          <p:cNvPr id="47" name="Shape 44"/>
+          <p:cNvPr id="77" name="Text 74"/>
+          <p:cNvSpPr/>
+          <p:nvPr/>
+        </p:nvSpPr>
+        <p:spPr>
+          <a:xfrm>
+            <a:off x="9957587" y="3721608"/>
+            <a:ext cx="329184" cy="329184"/>
+          </a:xfrm>
+          <a:prstGeom prst="rect">
+            <a:avLst/>
+          </a:prstGeom>
+          <a:noFill/>
+          <a:ln/>
+        </p:spPr>
+        <p:txBody>
+          <a:bodyPr wrap="square" rtlCol="0" anchor="ctr"/>
+          <a:lstStyle/>
+          <a:p>
+            <a:pPr algn="ctr" indent="0" marL="0">
+              <a:buNone/>
+            </a:pPr>
+            <a:r>
+              <a:rPr lang="en-US" sz="800" b="1" dirty="0">
+                <a:solidFill>
+                  <a:srgbClr val="FFFFFF"/>
+                </a:solidFill>
+                <a:latin typeface="Calibri" pitchFamily="34" charset="0"/>
+                <a:ea typeface="Calibri" pitchFamily="34" charset="-122"/>
+                <a:cs typeface="Calibri" pitchFamily="34" charset="-120"/>
+              </a:rPr>
+              <a:t>P4</a:t>
+            </a:r>
+            <a:endParaRPr lang="en-US" sz="800" dirty="0"/>
+          </a:p>
+        </p:txBody>
+      </p:sp>
+      <p:sp>
+        <p:nvSpPr>
+          <p:cNvPr id="78" name="Shape 75"/>
           <p:cNvSpPr/>
           <p:nvPr/>
         </p:nvSpPr>
@@ -8211,7 +9420,46 @@
       </p:sp>
       <p:sp>
         <p:nvSpPr>
-          <p:cNvPr id="48" name="Text 45"/>
+          <p:cNvPr id="79" name="Text 76"/>
+          <p:cNvSpPr/>
+          <p:nvPr/>
+        </p:nvSpPr>
+        <p:spPr>
+          <a:xfrm>
+            <a:off x="10341635" y="3721608"/>
+            <a:ext cx="329184" cy="329184"/>
+          </a:xfrm>
+          <a:prstGeom prst="rect">
+            <a:avLst/>
+          </a:prstGeom>
+          <a:noFill/>
+          <a:ln/>
+        </p:spPr>
+        <p:txBody>
+          <a:bodyPr wrap="square" rtlCol="0" anchor="ctr"/>
+          <a:lstStyle/>
+          <a:p>
+            <a:pPr algn="ctr" indent="0" marL="0">
+              <a:buNone/>
+            </a:pPr>
+            <a:r>
+              <a:rPr lang="en-US" sz="800" b="1" dirty="0">
+                <a:solidFill>
+                  <a:srgbClr val="FFFFFF"/>
+                </a:solidFill>
+                <a:latin typeface="Calibri" pitchFamily="34" charset="0"/>
+                <a:ea typeface="Calibri" pitchFamily="34" charset="-122"/>
+                <a:cs typeface="Calibri" pitchFamily="34" charset="-120"/>
+              </a:rPr>
+              <a:t>P4</a:t>
+            </a:r>
+            <a:endParaRPr lang="en-US" sz="800" dirty="0"/>
+          </a:p>
+        </p:txBody>
+      </p:sp>
+      <p:sp>
+        <p:nvSpPr>
+          <p:cNvPr id="80" name="Text 77"/>
           <p:cNvSpPr/>
           <p:nvPr/>
         </p:nvSpPr>
@@ -10487,9 +11735,9 @@
                 <a:solidFill>
                   <a:srgbClr val="1F2A52"/>
                 </a:solidFill>
-                <a:latin typeface="Consolas" pitchFamily="34" charset="0"/>
-                <a:ea typeface="Consolas" pitchFamily="34" charset="-122"/>
-                <a:cs typeface="Consolas" pitchFamily="34" charset="-120"/>
+                <a:latin typeface="Courier New" pitchFamily="34" charset="0"/>
+                <a:ea typeface="Courier New" pitchFamily="34" charset="-122"/>
+                <a:cs typeface="Courier New" pitchFamily="34" charset="-120"/>
               </a:rPr>
               <a:t>0.891</a:t>
             </a:r>
@@ -10612,9 +11860,9 @@
                 <a:solidFill>
                   <a:srgbClr val="1F2A52"/>
                 </a:solidFill>
-                <a:latin typeface="Consolas" pitchFamily="34" charset="0"/>
-                <a:ea typeface="Consolas" pitchFamily="34" charset="-122"/>
-                <a:cs typeface="Consolas" pitchFamily="34" charset="-120"/>
+                <a:latin typeface="Courier New" pitchFamily="34" charset="0"/>
+                <a:ea typeface="Courier New" pitchFamily="34" charset="-122"/>
+                <a:cs typeface="Courier New" pitchFamily="34" charset="-120"/>
               </a:rPr>
               <a:t>0.882</a:t>
             </a:r>
@@ -10737,9 +11985,9 @@
                 <a:solidFill>
                   <a:srgbClr val="1F2A52"/>
                 </a:solidFill>
-                <a:latin typeface="Consolas" pitchFamily="34" charset="0"/>
-                <a:ea typeface="Consolas" pitchFamily="34" charset="-122"/>
-                <a:cs typeface="Consolas" pitchFamily="34" charset="-120"/>
+                <a:latin typeface="Courier New" pitchFamily="34" charset="0"/>
+                <a:ea typeface="Courier New" pitchFamily="34" charset="-122"/>
+                <a:cs typeface="Courier New" pitchFamily="34" charset="-120"/>
               </a:rPr>
               <a:t>0.878</a:t>
             </a:r>
@@ -10862,9 +12110,9 @@
                 <a:solidFill>
                   <a:srgbClr val="1F2A52"/>
                 </a:solidFill>
-                <a:latin typeface="Consolas" pitchFamily="34" charset="0"/>
-                <a:ea typeface="Consolas" pitchFamily="34" charset="-122"/>
-                <a:cs typeface="Consolas" pitchFamily="34" charset="-120"/>
+                <a:latin typeface="Courier New" pitchFamily="34" charset="0"/>
+                <a:ea typeface="Courier New" pitchFamily="34" charset="-122"/>
+                <a:cs typeface="Courier New" pitchFamily="34" charset="-120"/>
               </a:rPr>
               <a:t>0.857</a:t>
             </a:r>
@@ -11537,16 +12785,16 @@
                           <a:solidFill>
                             <a:srgbClr val="6B7394"/>
                           </a:solidFill>
-                          <a:latin typeface="Consolas" pitchFamily="34" charset="0"/>
-                          <a:ea typeface="Consolas" pitchFamily="34" charset="-122"/>
-                          <a:cs typeface="Consolas" pitchFamily="34" charset="-120"/>
+                          <a:latin typeface="Courier New" pitchFamily="34" charset="0"/>
+                          <a:ea typeface="Courier New" pitchFamily="34" charset="-122"/>
+                          <a:cs typeface="Courier New" pitchFamily="34" charset="-120"/>
                         </a:rPr>
                         <a:t>0.8820</a:t>
                       </a:r>
                       <a:endParaRPr lang="en-US" sz="1200" dirty="0">
-                        <a:latin typeface="Consolas" charset="0"/>
-                        <a:ea typeface="Consolas" charset="0"/>
-                        <a:cs typeface="Consolas" charset="0"/>
+                        <a:latin typeface="Courier New" charset="0"/>
+                        <a:ea typeface="Courier New" charset="0"/>
+                        <a:cs typeface="Courier New" charset="0"/>
                       </a:endParaRPr>
                     </a:p>
                   </a:txBody>
@@ -11605,16 +12853,16 @@
                           <a:solidFill>
                             <a:srgbClr val="6B7394"/>
                           </a:solidFill>
-                          <a:latin typeface="Consolas" pitchFamily="34" charset="0"/>
-                          <a:ea typeface="Consolas" pitchFamily="34" charset="-122"/>
-                          <a:cs typeface="Consolas" pitchFamily="34" charset="-120"/>
+                          <a:latin typeface="Courier New" pitchFamily="34" charset="0"/>
+                          <a:ea typeface="Courier New" pitchFamily="34" charset="-122"/>
+                          <a:cs typeface="Courier New" pitchFamily="34" charset="-120"/>
                         </a:rPr>
                         <a:t>0.8572</a:t>
                       </a:r>
                       <a:endParaRPr lang="en-US" sz="1200" dirty="0">
-                        <a:latin typeface="Consolas" charset="0"/>
-                        <a:ea typeface="Consolas" charset="0"/>
-                        <a:cs typeface="Consolas" charset="0"/>
+                        <a:latin typeface="Courier New" charset="0"/>
+                        <a:ea typeface="Courier New" charset="0"/>
+                        <a:cs typeface="Courier New" charset="0"/>
                       </a:endParaRPr>
                     </a:p>
                   </a:txBody>
@@ -11673,16 +12921,16 @@
                           <a:solidFill>
                             <a:srgbClr val="6B7394"/>
                           </a:solidFill>
-                          <a:latin typeface="Consolas" pitchFamily="34" charset="0"/>
-                          <a:ea typeface="Consolas" pitchFamily="34" charset="-122"/>
-                          <a:cs typeface="Consolas" pitchFamily="34" charset="-120"/>
+                          <a:latin typeface="Courier New" pitchFamily="34" charset="0"/>
+                          <a:ea typeface="Courier New" pitchFamily="34" charset="-122"/>
+                          <a:cs typeface="Courier New" pitchFamily="34" charset="-120"/>
                         </a:rPr>
                         <a:t>0.8775</a:t>
                       </a:r>
                       <a:endParaRPr lang="en-US" sz="1200" dirty="0">
-                        <a:latin typeface="Consolas" charset="0"/>
-                        <a:ea typeface="Consolas" charset="0"/>
-                        <a:cs typeface="Consolas" charset="0"/>
+                        <a:latin typeface="Courier New" charset="0"/>
+                        <a:ea typeface="Courier New" charset="0"/>
+                        <a:cs typeface="Courier New" charset="0"/>
                       </a:endParaRPr>
                     </a:p>
                   </a:txBody>
@@ -11741,16 +12989,16 @@
                           <a:solidFill>
                             <a:srgbClr val="1F2A52"/>
                           </a:solidFill>
-                          <a:latin typeface="Consolas" pitchFamily="34" charset="0"/>
-                          <a:ea typeface="Consolas" pitchFamily="34" charset="-122"/>
-                          <a:cs typeface="Consolas" pitchFamily="34" charset="-120"/>
+                          <a:latin typeface="Courier New" pitchFamily="34" charset="0"/>
+                          <a:ea typeface="Courier New" pitchFamily="34" charset="-122"/>
+                          <a:cs typeface="Courier New" pitchFamily="34" charset="-120"/>
                         </a:rPr>
                         <a:t>0.8912</a:t>
                       </a:r>
                       <a:endParaRPr lang="en-US" sz="1200" dirty="0">
-                        <a:latin typeface="Consolas" charset="0"/>
-                        <a:ea typeface="Consolas" charset="0"/>
-                        <a:cs typeface="Consolas" charset="0"/>
+                        <a:latin typeface="Courier New" charset="0"/>
+                        <a:ea typeface="Courier New" charset="0"/>
+                        <a:cs typeface="Courier New" charset="0"/>
                       </a:endParaRPr>
                     </a:p>
                   </a:txBody>
@@ -11876,16 +13124,16 @@
                           <a:solidFill>
                             <a:srgbClr val="6B7394"/>
                           </a:solidFill>
-                          <a:latin typeface="Consolas" pitchFamily="34" charset="0"/>
-                          <a:ea typeface="Consolas" pitchFamily="34" charset="-122"/>
-                          <a:cs typeface="Consolas" pitchFamily="34" charset="-120"/>
+                          <a:latin typeface="Courier New" pitchFamily="34" charset="0"/>
+                          <a:ea typeface="Courier New" pitchFamily="34" charset="-122"/>
+                          <a:cs typeface="Courier New" pitchFamily="34" charset="-120"/>
                         </a:rPr>
                         <a:t>0.8198</a:t>
                       </a:r>
                       <a:endParaRPr lang="en-US" sz="1200" dirty="0">
-                        <a:latin typeface="Consolas" charset="0"/>
-                        <a:ea typeface="Consolas" charset="0"/>
-                        <a:cs typeface="Consolas" charset="0"/>
+                        <a:latin typeface="Courier New" charset="0"/>
+                        <a:ea typeface="Courier New" charset="0"/>
+                        <a:cs typeface="Courier New" charset="0"/>
                       </a:endParaRPr>
                     </a:p>
                   </a:txBody>
@@ -11944,16 +13192,16 @@
                           <a:solidFill>
                             <a:srgbClr val="6B7394"/>
                           </a:solidFill>
-                          <a:latin typeface="Consolas" pitchFamily="34" charset="0"/>
-                          <a:ea typeface="Consolas" pitchFamily="34" charset="-122"/>
-                          <a:cs typeface="Consolas" pitchFamily="34" charset="-120"/>
+                          <a:latin typeface="Courier New" pitchFamily="34" charset="0"/>
+                          <a:ea typeface="Courier New" pitchFamily="34" charset="-122"/>
+                          <a:cs typeface="Courier New" pitchFamily="34" charset="-120"/>
                         </a:rPr>
                         <a:t>0.7821</a:t>
                       </a:r>
                       <a:endParaRPr lang="en-US" sz="1200" dirty="0">
-                        <a:latin typeface="Consolas" charset="0"/>
-                        <a:ea typeface="Consolas" charset="0"/>
-                        <a:cs typeface="Consolas" charset="0"/>
+                        <a:latin typeface="Courier New" charset="0"/>
+                        <a:ea typeface="Courier New" charset="0"/>
+                        <a:cs typeface="Courier New" charset="0"/>
                       </a:endParaRPr>
                     </a:p>
                   </a:txBody>
@@ -12012,16 +13260,16 @@
                           <a:solidFill>
                             <a:srgbClr val="6B7394"/>
                           </a:solidFill>
-                          <a:latin typeface="Consolas" pitchFamily="34" charset="0"/>
-                          <a:ea typeface="Consolas" pitchFamily="34" charset="-122"/>
-                          <a:cs typeface="Consolas" pitchFamily="34" charset="-120"/>
+                          <a:latin typeface="Courier New" pitchFamily="34" charset="0"/>
+                          <a:ea typeface="Courier New" pitchFamily="34" charset="-122"/>
+                          <a:cs typeface="Courier New" pitchFamily="34" charset="-120"/>
                         </a:rPr>
                         <a:t>0.8078</a:t>
                       </a:r>
                       <a:endParaRPr lang="en-US" sz="1200" dirty="0">
-                        <a:latin typeface="Consolas" charset="0"/>
-                        <a:ea typeface="Consolas" charset="0"/>
-                        <a:cs typeface="Consolas" charset="0"/>
+                        <a:latin typeface="Courier New" charset="0"/>
+                        <a:ea typeface="Courier New" charset="0"/>
+                        <a:cs typeface="Courier New" charset="0"/>
                       </a:endParaRPr>
                     </a:p>
                   </a:txBody>
@@ -12080,16 +13328,16 @@
                           <a:solidFill>
                             <a:srgbClr val="1F2A52"/>
                           </a:solidFill>
-                          <a:latin typeface="Consolas" pitchFamily="34" charset="0"/>
-                          <a:ea typeface="Consolas" pitchFamily="34" charset="-122"/>
-                          <a:cs typeface="Consolas" pitchFamily="34" charset="-120"/>
+                          <a:latin typeface="Courier New" pitchFamily="34" charset="0"/>
+                          <a:ea typeface="Courier New" pitchFamily="34" charset="-122"/>
+                          <a:cs typeface="Courier New" pitchFamily="34" charset="-120"/>
                         </a:rPr>
                         <a:t>0.8304</a:t>
                       </a:r>
                       <a:endParaRPr lang="en-US" sz="1200" dirty="0">
-                        <a:latin typeface="Consolas" charset="0"/>
-                        <a:ea typeface="Consolas" charset="0"/>
-                        <a:cs typeface="Consolas" charset="0"/>
+                        <a:latin typeface="Courier New" charset="0"/>
+                        <a:ea typeface="Courier New" charset="0"/>
+                        <a:cs typeface="Courier New" charset="0"/>
                       </a:endParaRPr>
                     </a:p>
                   </a:txBody>
@@ -12215,16 +13463,16 @@
                           <a:solidFill>
                             <a:srgbClr val="6B7394"/>
                           </a:solidFill>
-                          <a:latin typeface="Consolas" pitchFamily="34" charset="0"/>
-                          <a:ea typeface="Consolas" pitchFamily="34" charset="-122"/>
-                          <a:cs typeface="Consolas" pitchFamily="34" charset="-120"/>
+                          <a:latin typeface="Courier New" pitchFamily="34" charset="0"/>
+                          <a:ea typeface="Courier New" pitchFamily="34" charset="-122"/>
+                          <a:cs typeface="Courier New" pitchFamily="34" charset="-120"/>
                         </a:rPr>
                         <a:t>0.8071</a:t>
                       </a:r>
                       <a:endParaRPr lang="en-US" sz="1200" dirty="0">
-                        <a:latin typeface="Consolas" charset="0"/>
-                        <a:ea typeface="Consolas" charset="0"/>
-                        <a:cs typeface="Consolas" charset="0"/>
+                        <a:latin typeface="Courier New" charset="0"/>
+                        <a:ea typeface="Courier New" charset="0"/>
+                        <a:cs typeface="Courier New" charset="0"/>
                       </a:endParaRPr>
                     </a:p>
                   </a:txBody>
@@ -12283,16 +13531,16 @@
                           <a:solidFill>
                             <a:srgbClr val="6B7394"/>
                           </a:solidFill>
-                          <a:latin typeface="Consolas" pitchFamily="34" charset="0"/>
-                          <a:ea typeface="Consolas" pitchFamily="34" charset="-122"/>
-                          <a:cs typeface="Consolas" pitchFamily="34" charset="-120"/>
+                          <a:latin typeface="Courier New" pitchFamily="34" charset="0"/>
+                          <a:ea typeface="Courier New" pitchFamily="34" charset="-122"/>
+                          <a:cs typeface="Courier New" pitchFamily="34" charset="-120"/>
                         </a:rPr>
                         <a:t>0.7777</a:t>
                       </a:r>
                       <a:endParaRPr lang="en-US" sz="1200" dirty="0">
-                        <a:latin typeface="Consolas" charset="0"/>
-                        <a:ea typeface="Consolas" charset="0"/>
-                        <a:cs typeface="Consolas" charset="0"/>
+                        <a:latin typeface="Courier New" charset="0"/>
+                        <a:ea typeface="Courier New" charset="0"/>
+                        <a:cs typeface="Courier New" charset="0"/>
                       </a:endParaRPr>
                     </a:p>
                   </a:txBody>
@@ -12351,16 +13599,16 @@
                           <a:solidFill>
                             <a:srgbClr val="6B7394"/>
                           </a:solidFill>
-                          <a:latin typeface="Consolas" pitchFamily="34" charset="0"/>
-                          <a:ea typeface="Consolas" pitchFamily="34" charset="-122"/>
-                          <a:cs typeface="Consolas" pitchFamily="34" charset="-120"/>
+                          <a:latin typeface="Courier New" pitchFamily="34" charset="0"/>
+                          <a:ea typeface="Courier New" pitchFamily="34" charset="-122"/>
+                          <a:cs typeface="Courier New" pitchFamily="34" charset="-120"/>
                         </a:rPr>
                         <a:t>0.7931</a:t>
                       </a:r>
                       <a:endParaRPr lang="en-US" sz="1200" dirty="0">
-                        <a:latin typeface="Consolas" charset="0"/>
-                        <a:ea typeface="Consolas" charset="0"/>
-                        <a:cs typeface="Consolas" charset="0"/>
+                        <a:latin typeface="Courier New" charset="0"/>
+                        <a:ea typeface="Courier New" charset="0"/>
+                        <a:cs typeface="Courier New" charset="0"/>
                       </a:endParaRPr>
                     </a:p>
                   </a:txBody>
@@ -12419,16 +13667,16 @@
                           <a:solidFill>
                             <a:srgbClr val="1F2A52"/>
                           </a:solidFill>
-                          <a:latin typeface="Consolas" pitchFamily="34" charset="0"/>
-                          <a:ea typeface="Consolas" pitchFamily="34" charset="-122"/>
-                          <a:cs typeface="Consolas" pitchFamily="34" charset="-120"/>
+                          <a:latin typeface="Courier New" pitchFamily="34" charset="0"/>
+                          <a:ea typeface="Courier New" pitchFamily="34" charset="-122"/>
+                          <a:cs typeface="Courier New" pitchFamily="34" charset="-120"/>
                         </a:rPr>
                         <a:t>0.8120</a:t>
                       </a:r>
                       <a:endParaRPr lang="en-US" sz="1200" dirty="0">
-                        <a:latin typeface="Consolas" charset="0"/>
-                        <a:ea typeface="Consolas" charset="0"/>
-                        <a:cs typeface="Consolas" charset="0"/>
+                        <a:latin typeface="Courier New" charset="0"/>
+                        <a:ea typeface="Courier New" charset="0"/>
+                        <a:cs typeface="Courier New" charset="0"/>
                       </a:endParaRPr>
                     </a:p>
                   </a:txBody>
@@ -12554,16 +13802,16 @@
                           <a:solidFill>
                             <a:srgbClr val="1F2A52"/>
                           </a:solidFill>
-                          <a:latin typeface="Consolas" pitchFamily="34" charset="0"/>
-                          <a:ea typeface="Consolas" pitchFamily="34" charset="-122"/>
-                          <a:cs typeface="Consolas" pitchFamily="34" charset="-120"/>
+                          <a:latin typeface="Courier New" pitchFamily="34" charset="0"/>
+                          <a:ea typeface="Courier New" pitchFamily="34" charset="-122"/>
+                          <a:cs typeface="Courier New" pitchFamily="34" charset="-120"/>
                         </a:rPr>
                         <a:t>0.6515</a:t>
                       </a:r>
                       <a:endParaRPr lang="en-US" sz="1200" dirty="0">
-                        <a:latin typeface="Consolas" charset="0"/>
-                        <a:ea typeface="Consolas" charset="0"/>
-                        <a:cs typeface="Consolas" charset="0"/>
+                        <a:latin typeface="Courier New" charset="0"/>
+                        <a:ea typeface="Courier New" charset="0"/>
+                        <a:cs typeface="Courier New" charset="0"/>
                       </a:endParaRPr>
                     </a:p>
                   </a:txBody>
@@ -12622,16 +13870,16 @@
                           <a:solidFill>
                             <a:srgbClr val="6B7394"/>
                           </a:solidFill>
-                          <a:latin typeface="Consolas" pitchFamily="34" charset="0"/>
-                          <a:ea typeface="Consolas" pitchFamily="34" charset="-122"/>
-                          <a:cs typeface="Consolas" pitchFamily="34" charset="-120"/>
+                          <a:latin typeface="Courier New" pitchFamily="34" charset="0"/>
+                          <a:ea typeface="Courier New" pitchFamily="34" charset="-122"/>
+                          <a:cs typeface="Courier New" pitchFamily="34" charset="-120"/>
                         </a:rPr>
                         <a:t>0.5517</a:t>
                       </a:r>
                       <a:endParaRPr lang="en-US" sz="1200" dirty="0">
-                        <a:latin typeface="Consolas" charset="0"/>
-                        <a:ea typeface="Consolas" charset="0"/>
-                        <a:cs typeface="Consolas" charset="0"/>
+                        <a:latin typeface="Courier New" charset="0"/>
+                        <a:ea typeface="Courier New" charset="0"/>
+                        <a:cs typeface="Courier New" charset="0"/>
                       </a:endParaRPr>
                     </a:p>
                   </a:txBody>
@@ -12690,16 +13938,16 @@
                           <a:solidFill>
                             <a:srgbClr val="6B7394"/>
                           </a:solidFill>
-                          <a:latin typeface="Consolas" pitchFamily="34" charset="0"/>
-                          <a:ea typeface="Consolas" pitchFamily="34" charset="-122"/>
-                          <a:cs typeface="Consolas" pitchFamily="34" charset="-120"/>
+                          <a:latin typeface="Courier New" pitchFamily="34" charset="0"/>
+                          <a:ea typeface="Courier New" pitchFamily="34" charset="-122"/>
+                          <a:cs typeface="Courier New" pitchFamily="34" charset="-120"/>
                         </a:rPr>
                         <a:t>0.5832</a:t>
                       </a:r>
                       <a:endParaRPr lang="en-US" sz="1200" dirty="0">
-                        <a:latin typeface="Consolas" charset="0"/>
-                        <a:ea typeface="Consolas" charset="0"/>
-                        <a:cs typeface="Consolas" charset="0"/>
+                        <a:latin typeface="Courier New" charset="0"/>
+                        <a:ea typeface="Courier New" charset="0"/>
+                        <a:cs typeface="Courier New" charset="0"/>
                       </a:endParaRPr>
                     </a:p>
                   </a:txBody>
@@ -12758,16 +14006,16 @@
                           <a:solidFill>
                             <a:srgbClr val="6B7394"/>
                           </a:solidFill>
-                          <a:latin typeface="Consolas" pitchFamily="34" charset="0"/>
-                          <a:ea typeface="Consolas" pitchFamily="34" charset="-122"/>
-                          <a:cs typeface="Consolas" pitchFamily="34" charset="-120"/>
+                          <a:latin typeface="Courier New" pitchFamily="34" charset="0"/>
+                          <a:ea typeface="Courier New" pitchFamily="34" charset="-122"/>
+                          <a:cs typeface="Courier New" pitchFamily="34" charset="-120"/>
                         </a:rPr>
                         <a:t>0.6188</a:t>
                       </a:r>
                       <a:endParaRPr lang="en-US" sz="1200" dirty="0">
-                        <a:latin typeface="Consolas" charset="0"/>
-                        <a:ea typeface="Consolas" charset="0"/>
-                        <a:cs typeface="Consolas" charset="0"/>
+                        <a:latin typeface="Courier New" charset="0"/>
+                        <a:ea typeface="Courier New" charset="0"/>
+                        <a:cs typeface="Courier New" charset="0"/>
                       </a:endParaRPr>
                     </a:p>
                   </a:txBody>
@@ -12893,16 +14141,16 @@
                           <a:solidFill>
                             <a:srgbClr val="6B7394"/>
                           </a:solidFill>
-                          <a:latin typeface="Consolas" pitchFamily="34" charset="0"/>
-                          <a:ea typeface="Consolas" pitchFamily="34" charset="-122"/>
-                          <a:cs typeface="Consolas" pitchFamily="34" charset="-120"/>
+                          <a:latin typeface="Courier New" pitchFamily="34" charset="0"/>
+                          <a:ea typeface="Courier New" pitchFamily="34" charset="-122"/>
+                          <a:cs typeface="Courier New" pitchFamily="34" charset="-120"/>
                         </a:rPr>
                         <a:t>0.8992</a:t>
                       </a:r>
                       <a:endParaRPr lang="en-US" sz="1200" dirty="0">
-                        <a:latin typeface="Consolas" charset="0"/>
-                        <a:ea typeface="Consolas" charset="0"/>
-                        <a:cs typeface="Consolas" charset="0"/>
+                        <a:latin typeface="Courier New" charset="0"/>
+                        <a:ea typeface="Courier New" charset="0"/>
+                        <a:cs typeface="Courier New" charset="0"/>
                       </a:endParaRPr>
                     </a:p>
                   </a:txBody>
@@ -12961,16 +14209,16 @@
                           <a:solidFill>
                             <a:srgbClr val="6B7394"/>
                           </a:solidFill>
-                          <a:latin typeface="Consolas" pitchFamily="34" charset="0"/>
-                          <a:ea typeface="Consolas" pitchFamily="34" charset="-122"/>
-                          <a:cs typeface="Consolas" pitchFamily="34" charset="-120"/>
+                          <a:latin typeface="Courier New" pitchFamily="34" charset="0"/>
+                          <a:ea typeface="Courier New" pitchFamily="34" charset="-122"/>
+                          <a:cs typeface="Courier New" pitchFamily="34" charset="-120"/>
                         </a:rPr>
                         <a:t>0.9115</a:t>
                       </a:r>
                       <a:endParaRPr lang="en-US" sz="1200" dirty="0">
-                        <a:latin typeface="Consolas" charset="0"/>
-                        <a:ea typeface="Consolas" charset="0"/>
-                        <a:cs typeface="Consolas" charset="0"/>
+                        <a:latin typeface="Courier New" charset="0"/>
+                        <a:ea typeface="Courier New" charset="0"/>
+                        <a:cs typeface="Courier New" charset="0"/>
                       </a:endParaRPr>
                     </a:p>
                   </a:txBody>
@@ -13029,16 +14277,16 @@
                           <a:solidFill>
                             <a:srgbClr val="6B7394"/>
                           </a:solidFill>
-                          <a:latin typeface="Consolas" pitchFamily="34" charset="0"/>
-                          <a:ea typeface="Consolas" pitchFamily="34" charset="-122"/>
-                          <a:cs typeface="Consolas" pitchFamily="34" charset="-120"/>
+                          <a:latin typeface="Courier New" pitchFamily="34" charset="0"/>
+                          <a:ea typeface="Courier New" pitchFamily="34" charset="-122"/>
+                          <a:cs typeface="Courier New" pitchFamily="34" charset="-120"/>
                         </a:rPr>
                         <a:t>0.9174</a:t>
                       </a:r>
                       <a:endParaRPr lang="en-US" sz="1200" dirty="0">
-                        <a:latin typeface="Consolas" charset="0"/>
-                        <a:ea typeface="Consolas" charset="0"/>
-                        <a:cs typeface="Consolas" charset="0"/>
+                        <a:latin typeface="Courier New" charset="0"/>
+                        <a:ea typeface="Courier New" charset="0"/>
+                        <a:cs typeface="Courier New" charset="0"/>
                       </a:endParaRPr>
                     </a:p>
                   </a:txBody>
@@ -13097,16 +14345,16 @@
                           <a:solidFill>
                             <a:srgbClr val="1F2A52"/>
                           </a:solidFill>
-                          <a:latin typeface="Consolas" pitchFamily="34" charset="0"/>
-                          <a:ea typeface="Consolas" pitchFamily="34" charset="-122"/>
-                          <a:cs typeface="Consolas" pitchFamily="34" charset="-120"/>
+                          <a:latin typeface="Courier New" pitchFamily="34" charset="0"/>
+                          <a:ea typeface="Courier New" pitchFamily="34" charset="-122"/>
+                          <a:cs typeface="Courier New" pitchFamily="34" charset="-120"/>
                         </a:rPr>
                         <a:t>0.9264</a:t>
                       </a:r>
                       <a:endParaRPr lang="en-US" sz="1200" dirty="0">
-                        <a:latin typeface="Consolas" charset="0"/>
-                        <a:ea typeface="Consolas" charset="0"/>
-                        <a:cs typeface="Consolas" charset="0"/>
+                        <a:latin typeface="Courier New" charset="0"/>
+                        <a:ea typeface="Courier New" charset="0"/>
+                        <a:cs typeface="Courier New" charset="0"/>
                       </a:endParaRPr>
                     </a:p>
                   </a:txBody>
@@ -13232,16 +14480,16 @@
                           <a:solidFill>
                             <a:srgbClr val="6B7394"/>
                           </a:solidFill>
-                          <a:latin typeface="Consolas" pitchFamily="34" charset="0"/>
-                          <a:ea typeface="Consolas" pitchFamily="34" charset="-122"/>
-                          <a:cs typeface="Consolas" pitchFamily="34" charset="-120"/>
+                          <a:latin typeface="Courier New" pitchFamily="34" charset="0"/>
+                          <a:ea typeface="Courier New" pitchFamily="34" charset="-122"/>
+                          <a:cs typeface="Courier New" pitchFamily="34" charset="-120"/>
                         </a:rPr>
                         <a:t>0.7938</a:t>
                       </a:r>
                       <a:endParaRPr lang="en-US" sz="1200" dirty="0">
-                        <a:latin typeface="Consolas" charset="0"/>
-                        <a:ea typeface="Consolas" charset="0"/>
-                        <a:cs typeface="Consolas" charset="0"/>
+                        <a:latin typeface="Courier New" charset="0"/>
+                        <a:ea typeface="Courier New" charset="0"/>
+                        <a:cs typeface="Courier New" charset="0"/>
                       </a:endParaRPr>
                     </a:p>
                   </a:txBody>
@@ -13300,16 +14548,16 @@
                           <a:solidFill>
                             <a:srgbClr val="6B7394"/>
                           </a:solidFill>
-                          <a:latin typeface="Consolas" pitchFamily="34" charset="0"/>
-                          <a:ea typeface="Consolas" pitchFamily="34" charset="-122"/>
-                          <a:cs typeface="Consolas" pitchFamily="34" charset="-120"/>
+                          <a:latin typeface="Courier New" pitchFamily="34" charset="0"/>
+                          <a:ea typeface="Courier New" pitchFamily="34" charset="-122"/>
+                          <a:cs typeface="Courier New" pitchFamily="34" charset="-120"/>
                         </a:rPr>
                         <a:t>0.7900</a:t>
                       </a:r>
                       <a:endParaRPr lang="en-US" sz="1200" dirty="0">
-                        <a:latin typeface="Consolas" charset="0"/>
-                        <a:ea typeface="Consolas" charset="0"/>
-                        <a:cs typeface="Consolas" charset="0"/>
+                        <a:latin typeface="Courier New" charset="0"/>
+                        <a:ea typeface="Courier New" charset="0"/>
+                        <a:cs typeface="Courier New" charset="0"/>
                       </a:endParaRPr>
                     </a:p>
                   </a:txBody>
@@ -13368,16 +14616,16 @@
                           <a:solidFill>
                             <a:srgbClr val="6B7394"/>
                           </a:solidFill>
-                          <a:latin typeface="Consolas" pitchFamily="34" charset="0"/>
-                          <a:ea typeface="Consolas" pitchFamily="34" charset="-122"/>
-                          <a:cs typeface="Consolas" pitchFamily="34" charset="-120"/>
+                          <a:latin typeface="Courier New" pitchFamily="34" charset="0"/>
+                          <a:ea typeface="Courier New" pitchFamily="34" charset="-122"/>
+                          <a:cs typeface="Courier New" pitchFamily="34" charset="-120"/>
                         </a:rPr>
                         <a:t>0.8071</a:t>
                       </a:r>
                       <a:endParaRPr lang="en-US" sz="1200" dirty="0">
-                        <a:latin typeface="Consolas" charset="0"/>
-                        <a:ea typeface="Consolas" charset="0"/>
-                        <a:cs typeface="Consolas" charset="0"/>
+                        <a:latin typeface="Courier New" charset="0"/>
+                        <a:ea typeface="Courier New" charset="0"/>
+                        <a:cs typeface="Courier New" charset="0"/>
                       </a:endParaRPr>
                     </a:p>
                   </a:txBody>
@@ -13436,16 +14684,16 @@
                           <a:solidFill>
                             <a:srgbClr val="1F2A52"/>
                           </a:solidFill>
-                          <a:latin typeface="Consolas" pitchFamily="34" charset="0"/>
-                          <a:ea typeface="Consolas" pitchFamily="34" charset="-122"/>
-                          <a:cs typeface="Consolas" pitchFamily="34" charset="-120"/>
+                          <a:latin typeface="Courier New" pitchFamily="34" charset="0"/>
+                          <a:ea typeface="Courier New" pitchFamily="34" charset="-122"/>
+                          <a:cs typeface="Courier New" pitchFamily="34" charset="-120"/>
                         </a:rPr>
                         <a:t>0.8335</a:t>
                       </a:r>
                       <a:endParaRPr lang="en-US" sz="1200" dirty="0">
-                        <a:latin typeface="Consolas" charset="0"/>
-                        <a:ea typeface="Consolas" charset="0"/>
-                        <a:cs typeface="Consolas" charset="0"/>
+                        <a:latin typeface="Courier New" charset="0"/>
+                        <a:ea typeface="Courier New" charset="0"/>
+                        <a:cs typeface="Courier New" charset="0"/>
                       </a:endParaRPr>
                     </a:p>
                   </a:txBody>
@@ -14014,9 +15262,9 @@
                 <a:solidFill>
                   <a:srgbClr val="9E2453"/>
                 </a:solidFill>
-                <a:latin typeface="Consolas" pitchFamily="34" charset="0"/>
-                <a:ea typeface="Consolas" pitchFamily="34" charset="-122"/>
-                <a:cs typeface="Consolas" pitchFamily="34" charset="-120"/>
+                <a:latin typeface="Courier New" pitchFamily="34" charset="0"/>
+                <a:ea typeface="Courier New" pitchFamily="34" charset="-122"/>
+                <a:cs typeface="Courier New" pitchFamily="34" charset="-120"/>
               </a:rPr>
               <a:t>327 · 343 · 358</a:t>
             </a:r>
@@ -14367,9 +15615,9 @@
                 <a:solidFill>
                   <a:srgbClr val="9E2453"/>
                 </a:solidFill>
-                <a:latin typeface="Consolas" pitchFamily="34" charset="0"/>
-                <a:ea typeface="Consolas" pitchFamily="34" charset="-122"/>
-                <a:cs typeface="Consolas" pitchFamily="34" charset="-120"/>
+                <a:latin typeface="Courier New" pitchFamily="34" charset="0"/>
+                <a:ea typeface="Courier New" pitchFamily="34" charset="-122"/>
+                <a:cs typeface="Courier New" pitchFamily="34" charset="-120"/>
               </a:rPr>
               <a:t>181 · 187 · 205</a:t>
             </a:r>

</xml_diff>